<commit_message>
feat: add project presentation documentation
</commit_message>
<xml_diff>
--- a/report/Smart_Campus_IoT_Presentation.pptx
+++ b/report/Smart_Campus_IoT_Presentation.pptx
@@ -5,15 +5,15 @@
     <p:sldMasterId id="2147483648" r:id="rId1"/>
   </p:sldMasterIdLst>
   <p:sldIdLst>
-    <p:sldId id="256" r:id="rId7"/>
-    <p:sldId id="257" r:id="rId8"/>
-    <p:sldId id="258" r:id="rId9"/>
-    <p:sldId id="259" r:id="rId10"/>
-    <p:sldId id="260" r:id="rId11"/>
-    <p:sldId id="261" r:id="rId12"/>
-    <p:sldId id="262" r:id="rId13"/>
+    <p:sldId id="256" r:id="rId2"/>
+    <p:sldId id="257" r:id="rId3"/>
+    <p:sldId id="258" r:id="rId4"/>
+    <p:sldId id="259" r:id="rId5"/>
+    <p:sldId id="260" r:id="rId6"/>
+    <p:sldId id="261" r:id="rId7"/>
+    <p:sldId id="262" r:id="rId8"/>
   </p:sldIdLst>
-  <p:sldSz cx="12188952" cy="6858000" type="screen4x3"/>
+  <p:sldSz cx="12188825" cy="6858000"/>
   <p:notesSz cx="6858000" cy="9144000"/>
   <p:defaultTextStyle>
     <a:defPPr>
@@ -110,6 +110,22 @@
       </a:defRPr>
     </a:lvl9pPr>
   </p:defaultTextStyle>
+  <p:extLst>
+    <p:ext uri="{EFAFB233-063F-42B5-8137-9DF3F51BA10A}">
+      <p15:sldGuideLst xmlns:p15="http://schemas.microsoft.com/office/powerpoint/2012/main">
+        <p15:guide id="1" orient="horz" pos="2160">
+          <p15:clr>
+            <a:srgbClr val="A4A3A4"/>
+          </p15:clr>
+        </p15:guide>
+        <p15:guide id="2" pos="2880">
+          <p15:clr>
+            <a:srgbClr val="A4A3A4"/>
+          </p15:clr>
+        </p15:guide>
+      </p15:sldGuideLst>
+    </p:ext>
+  </p:extLst>
 </p:presentation>
 </file>
 
@@ -151,10 +167,9 @@
           <a:lstStyle/>
           <a:p>
             <a:r>
-              <a:rPr lang="en-US" smtClean="0"/>
+              <a:rPr lang="en-US"/>
               <a:t>Click to edit Master title style</a:t>
             </a:r>
-            <a:endParaRPr lang="en-US"/>
           </a:p>
         </p:txBody>
       </p:sp>
@@ -270,10 +285,9 @@
           </a:lstStyle>
           <a:p>
             <a:r>
-              <a:rPr lang="en-US" smtClean="0"/>
+              <a:rPr lang="en-US"/>
               <a:t>Click to edit Master subtitle style</a:t>
             </a:r>
-            <a:endParaRPr lang="en-US"/>
           </a:p>
         </p:txBody>
       </p:sp>
@@ -294,7 +308,7 @@
           <a:p>
             <a:fld id="{5BCAD085-E8A6-8845-BD4E-CB4CCA059FC4}" type="datetimeFigureOut">
               <a:rPr lang="en-US" smtClean="0"/>
-              <a:t>1/27/13</a:t>
+              <a:t>7/24/2026</a:t>
             </a:fld>
             <a:endParaRPr lang="en-US"/>
           </a:p>
@@ -388,10 +402,9 @@
           <a:lstStyle/>
           <a:p>
             <a:r>
-              <a:rPr lang="en-US" smtClean="0"/>
+              <a:rPr lang="en-US"/>
               <a:t>Click to edit Master title style</a:t>
             </a:r>
-            <a:endParaRPr lang="en-US"/>
           </a:p>
         </p:txBody>
       </p:sp>
@@ -412,38 +425,37 @@
           <a:p>
             <a:pPr lvl="0"/>
             <a:r>
-              <a:rPr lang="en-US" smtClean="0"/>
+              <a:rPr lang="en-US"/>
               <a:t>Click to edit Master text styles</a:t>
             </a:r>
           </a:p>
           <a:p>
             <a:pPr lvl="1"/>
             <a:r>
-              <a:rPr lang="en-US" smtClean="0"/>
+              <a:rPr lang="en-US"/>
               <a:t>Second level</a:t>
             </a:r>
           </a:p>
           <a:p>
             <a:pPr lvl="2"/>
             <a:r>
-              <a:rPr lang="en-US" smtClean="0"/>
+              <a:rPr lang="en-US"/>
               <a:t>Third level</a:t>
             </a:r>
           </a:p>
           <a:p>
             <a:pPr lvl="3"/>
             <a:r>
-              <a:rPr lang="en-US" smtClean="0"/>
+              <a:rPr lang="en-US"/>
               <a:t>Fourth level</a:t>
             </a:r>
           </a:p>
           <a:p>
             <a:pPr lvl="4"/>
             <a:r>
-              <a:rPr lang="en-US" smtClean="0"/>
+              <a:rPr lang="en-US"/>
               <a:t>Fifth level</a:t>
             </a:r>
-            <a:endParaRPr lang="en-US"/>
           </a:p>
         </p:txBody>
       </p:sp>
@@ -464,7 +476,7 @@
           <a:p>
             <a:fld id="{5BCAD085-E8A6-8845-BD4E-CB4CCA059FC4}" type="datetimeFigureOut">
               <a:rPr lang="en-US" smtClean="0"/>
-              <a:t>1/27/13</a:t>
+              <a:t>7/24/2026</a:t>
             </a:fld>
             <a:endParaRPr lang="en-US"/>
           </a:p>
@@ -563,10 +575,9 @@
           <a:lstStyle/>
           <a:p>
             <a:r>
-              <a:rPr lang="en-US" smtClean="0"/>
+              <a:rPr lang="en-US"/>
               <a:t>Click to edit Master title style</a:t>
             </a:r>
-            <a:endParaRPr lang="en-US"/>
           </a:p>
         </p:txBody>
       </p:sp>
@@ -592,38 +603,37 @@
           <a:p>
             <a:pPr lvl="0"/>
             <a:r>
-              <a:rPr lang="en-US" smtClean="0"/>
+              <a:rPr lang="en-US"/>
               <a:t>Click to edit Master text styles</a:t>
             </a:r>
           </a:p>
           <a:p>
             <a:pPr lvl="1"/>
             <a:r>
-              <a:rPr lang="en-US" smtClean="0"/>
+              <a:rPr lang="en-US"/>
               <a:t>Second level</a:t>
             </a:r>
           </a:p>
           <a:p>
             <a:pPr lvl="2"/>
             <a:r>
-              <a:rPr lang="en-US" smtClean="0"/>
+              <a:rPr lang="en-US"/>
               <a:t>Third level</a:t>
             </a:r>
           </a:p>
           <a:p>
             <a:pPr lvl="3"/>
             <a:r>
-              <a:rPr lang="en-US" smtClean="0"/>
+              <a:rPr lang="en-US"/>
               <a:t>Fourth level</a:t>
             </a:r>
           </a:p>
           <a:p>
             <a:pPr lvl="4"/>
             <a:r>
-              <a:rPr lang="en-US" smtClean="0"/>
+              <a:rPr lang="en-US"/>
               <a:t>Fifth level</a:t>
             </a:r>
-            <a:endParaRPr lang="en-US"/>
           </a:p>
         </p:txBody>
       </p:sp>
@@ -644,7 +654,7 @@
           <a:p>
             <a:fld id="{5BCAD085-E8A6-8845-BD4E-CB4CCA059FC4}" type="datetimeFigureOut">
               <a:rPr lang="en-US" smtClean="0"/>
-              <a:t>1/27/13</a:t>
+              <a:t>7/24/2026</a:t>
             </a:fld>
             <a:endParaRPr lang="en-US"/>
           </a:p>
@@ -738,10 +748,9 @@
           <a:lstStyle/>
           <a:p>
             <a:r>
-              <a:rPr lang="en-US" smtClean="0"/>
+              <a:rPr lang="en-US"/>
               <a:t>Click to edit Master title style</a:t>
             </a:r>
-            <a:endParaRPr lang="en-US"/>
           </a:p>
         </p:txBody>
       </p:sp>
@@ -762,38 +771,37 @@
           <a:p>
             <a:pPr lvl="0"/>
             <a:r>
-              <a:rPr lang="en-US" smtClean="0"/>
+              <a:rPr lang="en-US"/>
               <a:t>Click to edit Master text styles</a:t>
             </a:r>
           </a:p>
           <a:p>
             <a:pPr lvl="1"/>
             <a:r>
-              <a:rPr lang="en-US" smtClean="0"/>
+              <a:rPr lang="en-US"/>
               <a:t>Second level</a:t>
             </a:r>
           </a:p>
           <a:p>
             <a:pPr lvl="2"/>
             <a:r>
-              <a:rPr lang="en-US" smtClean="0"/>
+              <a:rPr lang="en-US"/>
               <a:t>Third level</a:t>
             </a:r>
           </a:p>
           <a:p>
             <a:pPr lvl="3"/>
             <a:r>
-              <a:rPr lang="en-US" smtClean="0"/>
+              <a:rPr lang="en-US"/>
               <a:t>Fourth level</a:t>
             </a:r>
           </a:p>
           <a:p>
             <a:pPr lvl="4"/>
             <a:r>
-              <a:rPr lang="en-US" smtClean="0"/>
+              <a:rPr lang="en-US"/>
               <a:t>Fifth level</a:t>
             </a:r>
-            <a:endParaRPr lang="en-US"/>
           </a:p>
         </p:txBody>
       </p:sp>
@@ -814,7 +822,7 @@
           <a:p>
             <a:fld id="{5BCAD085-E8A6-8845-BD4E-CB4CCA059FC4}" type="datetimeFigureOut">
               <a:rPr lang="en-US" smtClean="0"/>
-              <a:t>1/27/13</a:t>
+              <a:t>7/24/2026</a:t>
             </a:fld>
             <a:endParaRPr lang="en-US"/>
           </a:p>
@@ -917,10 +925,9 @@
           </a:lstStyle>
           <a:p>
             <a:r>
-              <a:rPr lang="en-US" smtClean="0"/>
+              <a:rPr lang="en-US"/>
               <a:t>Click to edit Master title style</a:t>
             </a:r>
-            <a:endParaRPr lang="en-US"/>
           </a:p>
         </p:txBody>
       </p:sp>
@@ -1037,7 +1044,7 @@
           <a:p>
             <a:pPr lvl="0"/>
             <a:r>
-              <a:rPr lang="en-US" smtClean="0"/>
+              <a:rPr lang="en-US"/>
               <a:t>Click to edit Master text styles</a:t>
             </a:r>
           </a:p>
@@ -1060,7 +1067,7 @@
           <a:p>
             <a:fld id="{5BCAD085-E8A6-8845-BD4E-CB4CCA059FC4}" type="datetimeFigureOut">
               <a:rPr lang="en-US" smtClean="0"/>
-              <a:t>1/27/13</a:t>
+              <a:t>7/24/2026</a:t>
             </a:fld>
             <a:endParaRPr lang="en-US"/>
           </a:p>
@@ -1154,10 +1161,9 @@
           <a:lstStyle/>
           <a:p>
             <a:r>
-              <a:rPr lang="en-US" smtClean="0"/>
+              <a:rPr lang="en-US"/>
               <a:t>Click to edit Master title style</a:t>
             </a:r>
-            <a:endParaRPr lang="en-US"/>
           </a:p>
         </p:txBody>
       </p:sp>
@@ -1211,38 +1217,37 @@
           <a:p>
             <a:pPr lvl="0"/>
             <a:r>
-              <a:rPr lang="en-US" smtClean="0"/>
+              <a:rPr lang="en-US"/>
               <a:t>Click to edit Master text styles</a:t>
             </a:r>
           </a:p>
           <a:p>
             <a:pPr lvl="1"/>
             <a:r>
-              <a:rPr lang="en-US" smtClean="0"/>
+              <a:rPr lang="en-US"/>
               <a:t>Second level</a:t>
             </a:r>
           </a:p>
           <a:p>
             <a:pPr lvl="2"/>
             <a:r>
-              <a:rPr lang="en-US" smtClean="0"/>
+              <a:rPr lang="en-US"/>
               <a:t>Third level</a:t>
             </a:r>
           </a:p>
           <a:p>
             <a:pPr lvl="3"/>
             <a:r>
-              <a:rPr lang="en-US" smtClean="0"/>
+              <a:rPr lang="en-US"/>
               <a:t>Fourth level</a:t>
             </a:r>
           </a:p>
           <a:p>
             <a:pPr lvl="4"/>
             <a:r>
-              <a:rPr lang="en-US" smtClean="0"/>
+              <a:rPr lang="en-US"/>
               <a:t>Fifth level</a:t>
             </a:r>
-            <a:endParaRPr lang="en-US"/>
           </a:p>
         </p:txBody>
       </p:sp>
@@ -1296,38 +1301,37 @@
           <a:p>
             <a:pPr lvl="0"/>
             <a:r>
-              <a:rPr lang="en-US" smtClean="0"/>
+              <a:rPr lang="en-US"/>
               <a:t>Click to edit Master text styles</a:t>
             </a:r>
           </a:p>
           <a:p>
             <a:pPr lvl="1"/>
             <a:r>
-              <a:rPr lang="en-US" smtClean="0"/>
+              <a:rPr lang="en-US"/>
               <a:t>Second level</a:t>
             </a:r>
           </a:p>
           <a:p>
             <a:pPr lvl="2"/>
             <a:r>
-              <a:rPr lang="en-US" smtClean="0"/>
+              <a:rPr lang="en-US"/>
               <a:t>Third level</a:t>
             </a:r>
           </a:p>
           <a:p>
             <a:pPr lvl="3"/>
             <a:r>
-              <a:rPr lang="en-US" smtClean="0"/>
+              <a:rPr lang="en-US"/>
               <a:t>Fourth level</a:t>
             </a:r>
           </a:p>
           <a:p>
             <a:pPr lvl="4"/>
             <a:r>
-              <a:rPr lang="en-US" smtClean="0"/>
+              <a:rPr lang="en-US"/>
               <a:t>Fifth level</a:t>
             </a:r>
-            <a:endParaRPr lang="en-US"/>
           </a:p>
         </p:txBody>
       </p:sp>
@@ -1348,7 +1352,7 @@
           <a:p>
             <a:fld id="{5BCAD085-E8A6-8845-BD4E-CB4CCA059FC4}" type="datetimeFigureOut">
               <a:rPr lang="en-US" smtClean="0"/>
-              <a:t>1/27/13</a:t>
+              <a:t>7/24/2026</a:t>
             </a:fld>
             <a:endParaRPr lang="en-US"/>
           </a:p>
@@ -1446,10 +1450,9 @@
           </a:lstStyle>
           <a:p>
             <a:r>
-              <a:rPr lang="en-US" smtClean="0"/>
+              <a:rPr lang="en-US"/>
               <a:t>Click to edit Master title style</a:t>
             </a:r>
-            <a:endParaRPr lang="en-US"/>
           </a:p>
         </p:txBody>
       </p:sp>
@@ -1512,7 +1515,7 @@
           <a:p>
             <a:pPr lvl="0"/>
             <a:r>
-              <a:rPr lang="en-US" smtClean="0"/>
+              <a:rPr lang="en-US"/>
               <a:t>Click to edit Master text styles</a:t>
             </a:r>
           </a:p>
@@ -1568,38 +1571,37 @@
           <a:p>
             <a:pPr lvl="0"/>
             <a:r>
-              <a:rPr lang="en-US" smtClean="0"/>
+              <a:rPr lang="en-US"/>
               <a:t>Click to edit Master text styles</a:t>
             </a:r>
           </a:p>
           <a:p>
             <a:pPr lvl="1"/>
             <a:r>
-              <a:rPr lang="en-US" smtClean="0"/>
+              <a:rPr lang="en-US"/>
               <a:t>Second level</a:t>
             </a:r>
           </a:p>
           <a:p>
             <a:pPr lvl="2"/>
             <a:r>
-              <a:rPr lang="en-US" smtClean="0"/>
+              <a:rPr lang="en-US"/>
               <a:t>Third level</a:t>
             </a:r>
           </a:p>
           <a:p>
             <a:pPr lvl="3"/>
             <a:r>
-              <a:rPr lang="en-US" smtClean="0"/>
+              <a:rPr lang="en-US"/>
               <a:t>Fourth level</a:t>
             </a:r>
           </a:p>
           <a:p>
             <a:pPr lvl="4"/>
             <a:r>
-              <a:rPr lang="en-US" smtClean="0"/>
+              <a:rPr lang="en-US"/>
               <a:t>Fifth level</a:t>
             </a:r>
-            <a:endParaRPr lang="en-US"/>
           </a:p>
         </p:txBody>
       </p:sp>
@@ -1662,7 +1664,7 @@
           <a:p>
             <a:pPr lvl="0"/>
             <a:r>
-              <a:rPr lang="en-US" smtClean="0"/>
+              <a:rPr lang="en-US"/>
               <a:t>Click to edit Master text styles</a:t>
             </a:r>
           </a:p>
@@ -1718,38 +1720,37 @@
           <a:p>
             <a:pPr lvl="0"/>
             <a:r>
-              <a:rPr lang="en-US" smtClean="0"/>
+              <a:rPr lang="en-US"/>
               <a:t>Click to edit Master text styles</a:t>
             </a:r>
           </a:p>
           <a:p>
             <a:pPr lvl="1"/>
             <a:r>
-              <a:rPr lang="en-US" smtClean="0"/>
+              <a:rPr lang="en-US"/>
               <a:t>Second level</a:t>
             </a:r>
           </a:p>
           <a:p>
             <a:pPr lvl="2"/>
             <a:r>
-              <a:rPr lang="en-US" smtClean="0"/>
+              <a:rPr lang="en-US"/>
               <a:t>Third level</a:t>
             </a:r>
           </a:p>
           <a:p>
             <a:pPr lvl="3"/>
             <a:r>
-              <a:rPr lang="en-US" smtClean="0"/>
+              <a:rPr lang="en-US"/>
               <a:t>Fourth level</a:t>
             </a:r>
           </a:p>
           <a:p>
             <a:pPr lvl="4"/>
             <a:r>
-              <a:rPr lang="en-US" smtClean="0"/>
+              <a:rPr lang="en-US"/>
               <a:t>Fifth level</a:t>
             </a:r>
-            <a:endParaRPr lang="en-US"/>
           </a:p>
         </p:txBody>
       </p:sp>
@@ -1770,7 +1771,7 @@
           <a:p>
             <a:fld id="{5BCAD085-E8A6-8845-BD4E-CB4CCA059FC4}" type="datetimeFigureOut">
               <a:rPr lang="en-US" smtClean="0"/>
-              <a:t>1/27/13</a:t>
+              <a:t>7/24/2026</a:t>
             </a:fld>
             <a:endParaRPr lang="en-US"/>
           </a:p>
@@ -1864,10 +1865,9 @@
           <a:lstStyle/>
           <a:p>
             <a:r>
-              <a:rPr lang="en-US" smtClean="0"/>
+              <a:rPr lang="en-US"/>
               <a:t>Click to edit Master title style</a:t>
             </a:r>
-            <a:endParaRPr lang="en-US"/>
           </a:p>
         </p:txBody>
       </p:sp>
@@ -1888,7 +1888,7 @@
           <a:p>
             <a:fld id="{5BCAD085-E8A6-8845-BD4E-CB4CCA059FC4}" type="datetimeFigureOut">
               <a:rPr lang="en-US" smtClean="0"/>
-              <a:t>1/27/13</a:t>
+              <a:t>7/24/2026</a:t>
             </a:fld>
             <a:endParaRPr lang="en-US"/>
           </a:p>
@@ -1983,7 +1983,7 @@
           <a:p>
             <a:fld id="{5BCAD085-E8A6-8845-BD4E-CB4CCA059FC4}" type="datetimeFigureOut">
               <a:rPr lang="en-US" smtClean="0"/>
-              <a:t>1/27/13</a:t>
+              <a:t>7/24/2026</a:t>
             </a:fld>
             <a:endParaRPr lang="en-US"/>
           </a:p>
@@ -2086,10 +2086,9 @@
           </a:lstStyle>
           <a:p>
             <a:r>
-              <a:rPr lang="en-US" smtClean="0"/>
+              <a:rPr lang="en-US"/>
               <a:t>Click to edit Master title style</a:t>
             </a:r>
-            <a:endParaRPr lang="en-US"/>
           </a:p>
         </p:txBody>
       </p:sp>
@@ -2143,38 +2142,37 @@
           <a:p>
             <a:pPr lvl="0"/>
             <a:r>
-              <a:rPr lang="en-US" smtClean="0"/>
+              <a:rPr lang="en-US"/>
               <a:t>Click to edit Master text styles</a:t>
             </a:r>
           </a:p>
           <a:p>
             <a:pPr lvl="1"/>
             <a:r>
-              <a:rPr lang="en-US" smtClean="0"/>
+              <a:rPr lang="en-US"/>
               <a:t>Second level</a:t>
             </a:r>
           </a:p>
           <a:p>
             <a:pPr lvl="2"/>
             <a:r>
-              <a:rPr lang="en-US" smtClean="0"/>
+              <a:rPr lang="en-US"/>
               <a:t>Third level</a:t>
             </a:r>
           </a:p>
           <a:p>
             <a:pPr lvl="3"/>
             <a:r>
-              <a:rPr lang="en-US" smtClean="0"/>
+              <a:rPr lang="en-US"/>
               <a:t>Fourth level</a:t>
             </a:r>
           </a:p>
           <a:p>
             <a:pPr lvl="4"/>
             <a:r>
-              <a:rPr lang="en-US" smtClean="0"/>
+              <a:rPr lang="en-US"/>
               <a:t>Fifth level</a:t>
             </a:r>
-            <a:endParaRPr lang="en-US"/>
           </a:p>
         </p:txBody>
       </p:sp>
@@ -2237,7 +2235,7 @@
           <a:p>
             <a:pPr lvl="0"/>
             <a:r>
-              <a:rPr lang="en-US" smtClean="0"/>
+              <a:rPr lang="en-US"/>
               <a:t>Click to edit Master text styles</a:t>
             </a:r>
           </a:p>
@@ -2260,7 +2258,7 @@
           <a:p>
             <a:fld id="{5BCAD085-E8A6-8845-BD4E-CB4CCA059FC4}" type="datetimeFigureOut">
               <a:rPr lang="en-US" smtClean="0"/>
-              <a:t>1/27/13</a:t>
+              <a:t>7/24/2026</a:t>
             </a:fld>
             <a:endParaRPr lang="en-US"/>
           </a:p>
@@ -2363,10 +2361,9 @@
           </a:lstStyle>
           <a:p>
             <a:r>
-              <a:rPr lang="en-US" smtClean="0"/>
+              <a:rPr lang="en-US"/>
               <a:t>Click to edit Master title style</a:t>
             </a:r>
-            <a:endParaRPr lang="en-US"/>
           </a:p>
         </p:txBody>
       </p:sp>
@@ -2490,7 +2487,7 @@
           <a:p>
             <a:pPr lvl="0"/>
             <a:r>
-              <a:rPr lang="en-US" smtClean="0"/>
+              <a:rPr lang="en-US"/>
               <a:t>Click to edit Master text styles</a:t>
             </a:r>
           </a:p>
@@ -2513,7 +2510,7 @@
           <a:p>
             <a:fld id="{5BCAD085-E8A6-8845-BD4E-CB4CCA059FC4}" type="datetimeFigureOut">
               <a:rPr lang="en-US" smtClean="0"/>
-              <a:t>1/27/13</a:t>
+              <a:t>7/24/2026</a:t>
             </a:fld>
             <a:endParaRPr lang="en-US"/>
           </a:p>
@@ -2622,10 +2619,9 @@
           <a:lstStyle/>
           <a:p>
             <a:r>
-              <a:rPr lang="en-US" smtClean="0"/>
+              <a:rPr lang="en-US"/>
               <a:t>Click to edit Master title style</a:t>
             </a:r>
-            <a:endParaRPr lang="en-US"/>
           </a:p>
         </p:txBody>
       </p:sp>
@@ -2656,38 +2652,37 @@
           <a:p>
             <a:pPr lvl="0"/>
             <a:r>
-              <a:rPr lang="en-US" smtClean="0"/>
+              <a:rPr lang="en-US"/>
               <a:t>Click to edit Master text styles</a:t>
             </a:r>
           </a:p>
           <a:p>
             <a:pPr lvl="1"/>
             <a:r>
-              <a:rPr lang="en-US" smtClean="0"/>
+              <a:rPr lang="en-US"/>
               <a:t>Second level</a:t>
             </a:r>
           </a:p>
           <a:p>
             <a:pPr lvl="2"/>
             <a:r>
-              <a:rPr lang="en-US" smtClean="0"/>
+              <a:rPr lang="en-US"/>
               <a:t>Third level</a:t>
             </a:r>
           </a:p>
           <a:p>
             <a:pPr lvl="3"/>
             <a:r>
-              <a:rPr lang="en-US" smtClean="0"/>
+              <a:rPr lang="en-US"/>
               <a:t>Fourth level</a:t>
             </a:r>
           </a:p>
           <a:p>
             <a:pPr lvl="4"/>
             <a:r>
-              <a:rPr lang="en-US" smtClean="0"/>
+              <a:rPr lang="en-US"/>
               <a:t>Fifth level</a:t>
             </a:r>
-            <a:endParaRPr lang="en-US"/>
           </a:p>
         </p:txBody>
       </p:sp>
@@ -2726,7 +2721,7 @@
           <a:p>
             <a:fld id="{5BCAD085-E8A6-8845-BD4E-CB4CCA059FC4}" type="datetimeFigureOut">
               <a:rPr lang="en-US" smtClean="0"/>
-              <a:t>1/27/13</a:t>
+              <a:t>7/24/2026</a:t>
             </a:fld>
             <a:endParaRPr lang="en-US"/>
           </a:p>
@@ -3085,7 +3080,7 @@
 </file>
 
 <file path=ppt/slides/slide1.xml><?xml version="1.0" encoding="utf-8"?>
-<p:sld xmlns:a="http://schemas.openxmlformats.org/drawingml/2006/main" xmlns:p="http://schemas.openxmlformats.org/presentationml/2006/main" xmlns:r="http://schemas.openxmlformats.org/officeDocument/2006/relationships">
+<p:sld xmlns:a="http://schemas.openxmlformats.org/drawingml/2006/main" xmlns:r="http://schemas.openxmlformats.org/officeDocument/2006/relationships" xmlns:p="http://schemas.openxmlformats.org/presentationml/2006/main">
   <p:cSld>
     <p:spTree>
       <p:nvGrpSpPr>
@@ -3093,7 +3088,14 @@
         <p:cNvGrpSpPr/>
         <p:nvPr/>
       </p:nvGrpSpPr>
-      <p:grpSpPr/>
+      <p:grpSpPr>
+        <a:xfrm>
+          <a:off x="0" y="0"/>
+          <a:ext cx="0" cy="0"/>
+          <a:chOff x="0" y="0"/>
+          <a:chExt cx="0" cy="0"/>
+        </a:xfrm>
+      </p:grpSpPr>
       <p:sp>
         <p:nvSpPr>
           <p:cNvPr id="2" name="Rectangle 1"/>
@@ -3134,6 +3136,7 @@
           <a:lstStyle/>
           <a:p>
             <a:pPr algn="ctr"/>
+            <a:endParaRPr/>
           </a:p>
         </p:txBody>
       </p:sp>
@@ -3177,6 +3180,7 @@
           <a:lstStyle/>
           <a:p>
             <a:pPr algn="ctr"/>
+            <a:endParaRPr/>
           </a:p>
         </p:txBody>
       </p:sp>
@@ -3259,7 +3263,7 @@
         <p:spPr>
           <a:xfrm>
             <a:off x="914400" y="4937760"/>
-            <a:ext cx="10360152" cy="640080"/>
+            <a:ext cx="10360152" cy="338554"/>
           </a:xfrm>
           <a:prstGeom prst="rect">
             <a:avLst/>
@@ -3274,13 +3278,66 @@
           <a:p>
             <a:pPr algn="ctr"/>
             <a:r>
-              <a:rPr sz="1600" b="0">
+              <a:rPr sz="1600" b="0" dirty="0">
                 <a:solidFill>
                   <a:srgbClr val="FFFFFF"/>
                 </a:solidFill>
               </a:rPr>
-              <a:t>Team: Osama Haider  &amp;  Saba Al-wesabi</a:t>
-            </a:r>
+              <a:t>Team: </a:t>
+            </a:r>
+            <a:r>
+              <a:rPr lang="en-US" sz="1600" dirty="0">
+                <a:solidFill>
+                  <a:srgbClr val="FFFFFF"/>
+                </a:solidFill>
+              </a:rPr>
+              <a:t>Saba Al-</a:t>
+            </a:r>
+            <a:r>
+              <a:rPr lang="en-US" sz="1600" dirty="0" err="1">
+                <a:solidFill>
+                  <a:srgbClr val="FFFFFF"/>
+                </a:solidFill>
+              </a:rPr>
+              <a:t>wesabi</a:t>
+            </a:r>
+            <a:r>
+              <a:rPr lang="en-US" sz="1600" dirty="0">
+                <a:solidFill>
+                  <a:srgbClr val="FFFFFF"/>
+                </a:solidFill>
+              </a:rPr>
+              <a:t> </a:t>
+            </a:r>
+            <a:r>
+              <a:rPr sz="1600" b="0" dirty="0">
+                <a:solidFill>
+                  <a:srgbClr val="FFFFFF"/>
+                </a:solidFill>
+              </a:rPr>
+              <a:t>&amp;</a:t>
+            </a:r>
+            <a:r>
+              <a:rPr lang="ar-SA" sz="1600" b="0" dirty="0">
+                <a:solidFill>
+                  <a:srgbClr val="FFFFFF"/>
+                </a:solidFill>
+              </a:rPr>
+              <a:t> </a:t>
+            </a:r>
+            <a:r>
+              <a:rPr lang="en-US" sz="1600" dirty="0">
+                <a:solidFill>
+                  <a:srgbClr val="FFFFFF"/>
+                </a:solidFill>
+              </a:rPr>
+              <a:t>Osama Haider </a:t>
+            </a:r>
+            <a:endParaRPr sz="1600" b="0" dirty="0">
+              <a:solidFill>
+                <a:srgbClr val="FFFFFF"/>
+              </a:solidFill>
+            </a:endParaRPr>
           </a:p>
         </p:txBody>
       </p:sp>
@@ -3293,7 +3350,7 @@
 </file>
 
 <file path=ppt/slides/slide2.xml><?xml version="1.0" encoding="utf-8"?>
-<p:sld xmlns:a="http://schemas.openxmlformats.org/drawingml/2006/main" xmlns:p="http://schemas.openxmlformats.org/presentationml/2006/main" xmlns:r="http://schemas.openxmlformats.org/officeDocument/2006/relationships">
+<p:sld xmlns:a="http://schemas.openxmlformats.org/drawingml/2006/main" xmlns:r="http://schemas.openxmlformats.org/officeDocument/2006/relationships" xmlns:p="http://schemas.openxmlformats.org/presentationml/2006/main">
   <p:cSld>
     <p:spTree>
       <p:nvGrpSpPr>
@@ -3301,7 +3358,14 @@
         <p:cNvGrpSpPr/>
         <p:nvPr/>
       </p:nvGrpSpPr>
-      <p:grpSpPr/>
+      <p:grpSpPr>
+        <a:xfrm>
+          <a:off x="0" y="0"/>
+          <a:ext cx="0" cy="0"/>
+          <a:chOff x="0" y="0"/>
+          <a:chExt cx="0" cy="0"/>
+        </a:xfrm>
+      </p:grpSpPr>
       <p:sp>
         <p:nvSpPr>
           <p:cNvPr id="2" name="Rectangle 1"/>
@@ -3342,6 +3406,7 @@
           <a:lstStyle/>
           <a:p>
             <a:pPr algn="ctr"/>
+            <a:endParaRPr sz="2000"/>
           </a:p>
         </p:txBody>
       </p:sp>
@@ -3385,6 +3450,7 @@
           <a:lstStyle/>
           <a:p>
             <a:pPr algn="ctr"/>
+            <a:endParaRPr sz="2000"/>
           </a:p>
         </p:txBody>
       </p:sp>
@@ -3397,7 +3463,7 @@
         <p:spPr>
           <a:xfrm>
             <a:off x="274320" y="137160"/>
-            <a:ext cx="10972800" cy="731520"/>
+            <a:ext cx="10972800" cy="584775"/>
           </a:xfrm>
           <a:prstGeom prst="rect">
             <a:avLst/>
@@ -3412,7 +3478,7 @@
           <a:p>
             <a:pPr algn="l"/>
             <a:r>
-              <a:rPr sz="2800" b="1">
+              <a:rPr sz="3200" b="1">
                 <a:solidFill>
                   <a:srgbClr val="FFFFFF"/>
                 </a:solidFill>
@@ -3446,7 +3512,7 @@
           <a:p>
             <a:pPr algn="l"/>
             <a:r>
-              <a:rPr sz="1800" b="1">
+              <a:rPr sz="2000" b="1">
                 <a:solidFill>
                   <a:srgbClr val="2E75B6"/>
                 </a:solidFill>
@@ -3465,7 +3531,7 @@
         <p:spPr>
           <a:xfrm>
             <a:off x="365760" y="1691640"/>
-            <a:ext cx="5394960" cy="2286000"/>
+            <a:ext cx="5394960" cy="1231106"/>
           </a:xfrm>
           <a:prstGeom prst="rect">
             <a:avLst/>
@@ -3484,7 +3550,7 @@
               </a:spcAft>
             </a:pPr>
             <a:r>
-              <a:rPr sz="1500">
+              <a:rPr sz="1600" dirty="0">
                 <a:solidFill>
                   <a:srgbClr val="1A1A2E"/>
                 </a:solidFill>
@@ -3499,7 +3565,7 @@
               </a:spcAft>
             </a:pPr>
             <a:r>
-              <a:rPr sz="1500">
+              <a:rPr sz="1600" dirty="0">
                 <a:solidFill>
                   <a:srgbClr val="1A1A2E"/>
                 </a:solidFill>
@@ -3514,7 +3580,7 @@
               </a:spcAft>
             </a:pPr>
             <a:r>
-              <a:rPr sz="1500">
+              <a:rPr sz="1600" dirty="0">
                 <a:solidFill>
                   <a:srgbClr val="1A1A2E"/>
                 </a:solidFill>
@@ -3548,7 +3614,7 @@
           <a:p>
             <a:pPr algn="l"/>
             <a:r>
-              <a:rPr sz="1800" b="1">
+              <a:rPr sz="2000" b="1">
                 <a:solidFill>
                   <a:srgbClr val="2E75B6"/>
                 </a:solidFill>
@@ -3567,7 +3633,7 @@
         <p:spPr>
           <a:xfrm>
             <a:off x="6400800" y="1691640"/>
-            <a:ext cx="5394960" cy="2743200"/>
+            <a:ext cx="5394960" cy="1631216"/>
           </a:xfrm>
           <a:prstGeom prst="rect">
             <a:avLst/>
@@ -3586,7 +3652,7 @@
               </a:spcAft>
             </a:pPr>
             <a:r>
-              <a:rPr sz="1500">
+              <a:rPr sz="1600" dirty="0">
                 <a:solidFill>
                   <a:srgbClr val="1A1A2E"/>
                 </a:solidFill>
@@ -3601,7 +3667,7 @@
               </a:spcAft>
             </a:pPr>
             <a:r>
-              <a:rPr sz="1500">
+              <a:rPr sz="1600" dirty="0">
                 <a:solidFill>
                   <a:srgbClr val="1A1A2E"/>
                 </a:solidFill>
@@ -3616,7 +3682,7 @@
               </a:spcAft>
             </a:pPr>
             <a:r>
-              <a:rPr sz="1500">
+              <a:rPr sz="1600" dirty="0">
                 <a:solidFill>
                   <a:srgbClr val="1A1A2E"/>
                 </a:solidFill>
@@ -3631,7 +3697,7 @@
               </a:spcAft>
             </a:pPr>
             <a:r>
-              <a:rPr sz="1500">
+              <a:rPr sz="1600" dirty="0">
                 <a:solidFill>
                   <a:srgbClr val="1A1A2E"/>
                 </a:solidFill>
@@ -3646,7 +3712,7 @@
               </a:spcAft>
             </a:pPr>
             <a:r>
-              <a:rPr sz="1500">
+              <a:rPr sz="1600" dirty="0">
                 <a:solidFill>
                   <a:srgbClr val="1A1A2E"/>
                 </a:solidFill>
@@ -3664,7 +3730,7 @@
         </p:nvSpPr>
         <p:spPr>
           <a:xfrm>
-            <a:off x="365760" y="5120640"/>
+            <a:off x="210185" y="4772947"/>
             <a:ext cx="11430000" cy="1371600"/>
           </a:xfrm>
           <a:prstGeom prst="rect">
@@ -3696,6 +3762,7 @@
           <a:lstStyle/>
           <a:p>
             <a:pPr algn="ctr"/>
+            <a:endParaRPr sz="2000"/>
           </a:p>
         </p:txBody>
       </p:sp>
@@ -3708,7 +3775,7 @@
         <p:spPr>
           <a:xfrm>
             <a:off x="548640" y="5166360"/>
-            <a:ext cx="10972800" cy="1188720"/>
+            <a:ext cx="10972800" cy="584775"/>
           </a:xfrm>
           <a:prstGeom prst="rect">
             <a:avLst/>
@@ -3723,7 +3790,7 @@
           <a:p>
             <a:pPr algn="l"/>
             <a:r>
-              <a:rPr sz="1500" b="0">
+              <a:rPr sz="1600" b="0">
                 <a:solidFill>
                   <a:srgbClr val="1A1A2E"/>
                 </a:solidFill>
@@ -3743,7 +3810,7 @@
 </file>
 
 <file path=ppt/slides/slide3.xml><?xml version="1.0" encoding="utf-8"?>
-<p:sld xmlns:a="http://schemas.openxmlformats.org/drawingml/2006/main" xmlns:p="http://schemas.openxmlformats.org/presentationml/2006/main" xmlns:r="http://schemas.openxmlformats.org/officeDocument/2006/relationships">
+<p:sld xmlns:a="http://schemas.openxmlformats.org/drawingml/2006/main" xmlns:r="http://schemas.openxmlformats.org/officeDocument/2006/relationships" xmlns:p="http://schemas.openxmlformats.org/presentationml/2006/main">
   <p:cSld>
     <p:spTree>
       <p:nvGrpSpPr>
@@ -3751,7 +3818,14 @@
         <p:cNvGrpSpPr/>
         <p:nvPr/>
       </p:nvGrpSpPr>
-      <p:grpSpPr/>
+      <p:grpSpPr>
+        <a:xfrm>
+          <a:off x="0" y="0"/>
+          <a:ext cx="0" cy="0"/>
+          <a:chOff x="0" y="0"/>
+          <a:chExt cx="0" cy="0"/>
+        </a:xfrm>
+      </p:grpSpPr>
       <p:sp>
         <p:nvSpPr>
           <p:cNvPr id="2" name="Rectangle 1"/>
@@ -3792,6 +3866,7 @@
           <a:lstStyle/>
           <a:p>
             <a:pPr algn="ctr"/>
+            <a:endParaRPr sz="2000"/>
           </a:p>
         </p:txBody>
       </p:sp>
@@ -3835,6 +3910,7 @@
           <a:lstStyle/>
           <a:p>
             <a:pPr algn="ctr"/>
+            <a:endParaRPr sz="2000"/>
           </a:p>
         </p:txBody>
       </p:sp>
@@ -3847,7 +3923,7 @@
         <p:spPr>
           <a:xfrm>
             <a:off x="274320" y="137160"/>
-            <a:ext cx="10972800" cy="731520"/>
+            <a:ext cx="10972800" cy="584775"/>
           </a:xfrm>
           <a:prstGeom prst="rect">
             <a:avLst/>
@@ -3862,7 +3938,7 @@
           <a:p>
             <a:pPr algn="l"/>
             <a:r>
-              <a:rPr sz="2800" b="1">
+              <a:rPr sz="3200" b="1">
                 <a:solidFill>
                   <a:srgbClr val="FFFFFF"/>
                 </a:solidFill>
@@ -3912,6 +3988,7 @@
           <a:lstStyle/>
           <a:p>
             <a:pPr algn="ctr"/>
+            <a:endParaRPr sz="2000"/>
           </a:p>
         </p:txBody>
       </p:sp>
@@ -3923,8 +4000,8 @@
         </p:nvSpPr>
         <p:spPr>
           <a:xfrm>
-            <a:off x="320040" y="1298448"/>
-            <a:ext cx="2743200" cy="457200"/>
+            <a:off x="320040" y="1365734"/>
+            <a:ext cx="2743200" cy="307777"/>
           </a:xfrm>
           <a:prstGeom prst="rect">
             <a:avLst/>
@@ -3939,7 +4016,7 @@
           <a:p>
             <a:pPr algn="ctr"/>
             <a:r>
-              <a:rPr sz="1300" b="1">
+              <a:rPr sz="1400" b="1">
                 <a:solidFill>
                   <a:srgbClr val="FFFFFF"/>
                 </a:solidFill>
@@ -3989,6 +4066,7 @@
           <a:lstStyle/>
           <a:p>
             <a:pPr algn="ctr"/>
+            <a:endParaRPr sz="2000"/>
           </a:p>
         </p:txBody>
       </p:sp>
@@ -4001,7 +4079,7 @@
         <p:spPr>
           <a:xfrm>
             <a:off x="365759" y="1810512"/>
-            <a:ext cx="2651760" cy="1234440"/>
+            <a:ext cx="2651760" cy="738664"/>
           </a:xfrm>
           <a:prstGeom prst="rect">
             <a:avLst/>
@@ -4016,47 +4094,13 @@
           <a:p>
             <a:pPr algn="l"/>
             <a:r>
-              <a:rPr sz="1200" b="0">
+              <a:rPr sz="1400" b="0" dirty="0">
                 <a:solidFill>
                   <a:srgbClr val="1A1A2E"/>
                 </a:solidFill>
               </a:rPr>
               <a:t>7 Virtual Devices (Python)
 Temp | Humidity | Occupancy | Light | Air Quality</a:t>
-            </a:r>
-          </a:p>
-        </p:txBody>
-      </p:sp>
-      <p:sp>
-        <p:nvSpPr>
-          <p:cNvPr id="9" name="TextBox 8"/>
-          <p:cNvSpPr txBox="1"/>
-          <p:nvPr/>
-        </p:nvSpPr>
-        <p:spPr>
-          <a:xfrm>
-            <a:off x="3017520" y="2194560"/>
-            <a:ext cx="274320" cy="457200"/>
-          </a:xfrm>
-          <a:prstGeom prst="rect">
-            <a:avLst/>
-          </a:prstGeom>
-          <a:noFill/>
-        </p:spPr>
-        <p:txBody>
-          <a:bodyPr wrap="square">
-            <a:spAutoFit/>
-          </a:bodyPr>
-          <a:lstStyle/>
-          <a:p>
-            <a:pPr algn="l"/>
-            <a:r>
-              <a:rPr sz="2200" b="1">
-                <a:solidFill>
-                  <a:srgbClr val="2E75B6"/>
-                </a:solidFill>
-              </a:rPr>
-              <a:t>→</a:t>
             </a:r>
           </a:p>
         </p:txBody>
@@ -4101,6 +4145,7 @@
           <a:lstStyle/>
           <a:p>
             <a:pPr algn="ctr"/>
+            <a:endParaRPr sz="2000"/>
           </a:p>
         </p:txBody>
       </p:sp>
@@ -4112,8 +4157,8 @@
         </p:nvSpPr>
         <p:spPr>
           <a:xfrm>
-            <a:off x="3264408" y="1298448"/>
-            <a:ext cx="2743200" cy="457200"/>
+            <a:off x="3264408" y="1377732"/>
+            <a:ext cx="2743200" cy="307777"/>
           </a:xfrm>
           <a:prstGeom prst="rect">
             <a:avLst/>
@@ -4128,7 +4173,7 @@
           <a:p>
             <a:pPr algn="ctr"/>
             <a:r>
-              <a:rPr sz="1300" b="1">
+              <a:rPr sz="1400" b="1" dirty="0">
                 <a:solidFill>
                   <a:srgbClr val="FFFFFF"/>
                 </a:solidFill>
@@ -4178,6 +4223,7 @@
           <a:lstStyle/>
           <a:p>
             <a:pPr algn="ctr"/>
+            <a:endParaRPr sz="2000"/>
           </a:p>
         </p:txBody>
       </p:sp>
@@ -4190,7 +4236,7 @@
         <p:spPr>
           <a:xfrm>
             <a:off x="3310128" y="1810512"/>
-            <a:ext cx="2651760" cy="1234440"/>
+            <a:ext cx="2651760" cy="954107"/>
           </a:xfrm>
           <a:prstGeom prst="rect">
             <a:avLst/>
@@ -4205,47 +4251,13 @@
           <a:p>
             <a:pPr algn="l"/>
             <a:r>
-              <a:rPr sz="1200" b="0">
+              <a:rPr sz="1400" b="0">
                 <a:solidFill>
                   <a:srgbClr val="1A1A2E"/>
                 </a:solidFill>
               </a:rPr>
               <a:t>MQTT via HiveMQ Public Broker
 Topic: campus/{building}/{room}/{deviceId}/telemetry</a:t>
-            </a:r>
-          </a:p>
-        </p:txBody>
-      </p:sp>
-      <p:sp>
-        <p:nvSpPr>
-          <p:cNvPr id="14" name="TextBox 13"/>
-          <p:cNvSpPr txBox="1"/>
-          <p:nvPr/>
-        </p:nvSpPr>
-        <p:spPr>
-          <a:xfrm>
-            <a:off x="5961888" y="2194560"/>
-            <a:ext cx="274320" cy="457200"/>
-          </a:xfrm>
-          <a:prstGeom prst="rect">
-            <a:avLst/>
-          </a:prstGeom>
-          <a:noFill/>
-        </p:spPr>
-        <p:txBody>
-          <a:bodyPr wrap="square">
-            <a:spAutoFit/>
-          </a:bodyPr>
-          <a:lstStyle/>
-          <a:p>
-            <a:pPr algn="l"/>
-            <a:r>
-              <a:rPr sz="2200" b="1">
-                <a:solidFill>
-                  <a:srgbClr val="2E75B6"/>
-                </a:solidFill>
-              </a:rPr>
-              <a:t>→</a:t>
             </a:r>
           </a:p>
         </p:txBody>
@@ -4290,6 +4302,7 @@
           <a:lstStyle/>
           <a:p>
             <a:pPr algn="ctr"/>
+            <a:endParaRPr sz="2000"/>
           </a:p>
         </p:txBody>
       </p:sp>
@@ -4301,8 +4314,8 @@
         </p:nvSpPr>
         <p:spPr>
           <a:xfrm>
-            <a:off x="6208776" y="1298448"/>
-            <a:ext cx="2743200" cy="457200"/>
+            <a:off x="6208776" y="1377732"/>
+            <a:ext cx="2743200" cy="307777"/>
           </a:xfrm>
           <a:prstGeom prst="rect">
             <a:avLst/>
@@ -4317,7 +4330,7 @@
           <a:p>
             <a:pPr algn="ctr"/>
             <a:r>
-              <a:rPr sz="1300" b="1">
+              <a:rPr sz="1400" b="1" dirty="0">
                 <a:solidFill>
                   <a:srgbClr val="FFFFFF"/>
                 </a:solidFill>
@@ -4367,6 +4380,7 @@
           <a:lstStyle/>
           <a:p>
             <a:pPr algn="ctr"/>
+            <a:endParaRPr sz="2000"/>
           </a:p>
         </p:txBody>
       </p:sp>
@@ -4379,7 +4393,7 @@
         <p:spPr>
           <a:xfrm>
             <a:off x="6254496" y="1810512"/>
-            <a:ext cx="2651760" cy="1234440"/>
+            <a:ext cx="2651760" cy="738664"/>
           </a:xfrm>
           <a:prstGeom prst="rect">
             <a:avLst/>
@@ -4394,47 +4408,13 @@
           <a:p>
             <a:pPr algn="l"/>
             <a:r>
-              <a:rPr sz="1200" b="0">
+              <a:rPr sz="1400" b="0">
                 <a:solidFill>
                   <a:srgbClr val="1A1A2E"/>
                 </a:solidFill>
               </a:rPr>
               <a:t>subscriber.py — Validation + Derived Values + Alerts
 Excel export with retry logic</a:t>
-            </a:r>
-          </a:p>
-        </p:txBody>
-      </p:sp>
-      <p:sp>
-        <p:nvSpPr>
-          <p:cNvPr id="19" name="TextBox 18"/>
-          <p:cNvSpPr txBox="1"/>
-          <p:nvPr/>
-        </p:nvSpPr>
-        <p:spPr>
-          <a:xfrm>
-            <a:off x="8906256" y="2194560"/>
-            <a:ext cx="274320" cy="457200"/>
-          </a:xfrm>
-          <a:prstGeom prst="rect">
-            <a:avLst/>
-          </a:prstGeom>
-          <a:noFill/>
-        </p:spPr>
-        <p:txBody>
-          <a:bodyPr wrap="square">
-            <a:spAutoFit/>
-          </a:bodyPr>
-          <a:lstStyle/>
-          <a:p>
-            <a:pPr algn="l"/>
-            <a:r>
-              <a:rPr sz="2200" b="1">
-                <a:solidFill>
-                  <a:srgbClr val="2E75B6"/>
-                </a:solidFill>
-              </a:rPr>
-              <a:t>→</a:t>
             </a:r>
           </a:p>
         </p:txBody>
@@ -4479,6 +4459,7 @@
           <a:lstStyle/>
           <a:p>
             <a:pPr algn="ctr"/>
+            <a:endParaRPr sz="2000"/>
           </a:p>
         </p:txBody>
       </p:sp>
@@ -4490,8 +4471,8 @@
         </p:nvSpPr>
         <p:spPr>
           <a:xfrm>
-            <a:off x="9153144" y="1298448"/>
-            <a:ext cx="2743200" cy="457200"/>
+            <a:off x="9153144" y="1347287"/>
+            <a:ext cx="2743200" cy="307777"/>
           </a:xfrm>
           <a:prstGeom prst="rect">
             <a:avLst/>
@@ -4506,7 +4487,7 @@
           <a:p>
             <a:pPr algn="ctr"/>
             <a:r>
-              <a:rPr sz="1300" b="1">
+              <a:rPr sz="1400" b="1" dirty="0">
                 <a:solidFill>
                   <a:srgbClr val="FFFFFF"/>
                 </a:solidFill>
@@ -4556,6 +4537,7 @@
           <a:lstStyle/>
           <a:p>
             <a:pPr algn="ctr"/>
+            <a:endParaRPr sz="2000"/>
           </a:p>
         </p:txBody>
       </p:sp>
@@ -4568,7 +4550,7 @@
         <p:spPr>
           <a:xfrm>
             <a:off x="9198864" y="1810512"/>
-            <a:ext cx="2651760" cy="1234440"/>
+            <a:ext cx="2651760" cy="738664"/>
           </a:xfrm>
           <a:prstGeom prst="rect">
             <a:avLst/>
@@ -4583,7 +4565,7 @@
           <a:p>
             <a:pPr algn="l"/>
             <a:r>
-              <a:rPr sz="1200" b="0">
+              <a:rPr sz="1400" b="0">
                 <a:solidFill>
                   <a:srgbClr val="1A1A2E"/>
                 </a:solidFill>
@@ -4603,7 +4585,7 @@
         <p:spPr>
           <a:xfrm>
             <a:off x="457200" y="3291840"/>
-            <a:ext cx="11247120" cy="457200"/>
+            <a:ext cx="11247120" cy="338554"/>
           </a:xfrm>
           <a:prstGeom prst="rect">
             <a:avLst/>
@@ -4618,7 +4600,7 @@
           <a:p>
             <a:pPr algn="ctr"/>
             <a:r>
-              <a:rPr sz="1400" b="0">
+              <a:rPr sz="1600" b="0">
                 <a:solidFill>
                   <a:srgbClr val="2E75B6"/>
                 </a:solidFill>
@@ -4637,7 +4619,7 @@
         <p:spPr>
           <a:xfrm>
             <a:off x="457200" y="3749039"/>
-            <a:ext cx="11247120" cy="411480"/>
+            <a:ext cx="11247120" cy="307777"/>
           </a:xfrm>
           <a:prstGeom prst="rect">
             <a:avLst/>
@@ -4652,7 +4634,7 @@
           <a:p>
             <a:pPr algn="ctr"/>
             <a:r>
-              <a:rPr sz="1300" b="0">
+              <a:rPr sz="1400" b="0">
                 <a:solidFill>
                   <a:srgbClr val="1A1A2E"/>
                 </a:solidFill>
@@ -4702,6 +4684,7 @@
           <a:lstStyle/>
           <a:p>
             <a:pPr algn="ctr"/>
+            <a:endParaRPr sz="2000"/>
           </a:p>
         </p:txBody>
       </p:sp>
@@ -4714,7 +4697,7 @@
         <p:spPr>
           <a:xfrm>
             <a:off x="365759" y="4379976"/>
-            <a:ext cx="2194560" cy="274320"/>
+            <a:ext cx="2194560" cy="307777"/>
           </a:xfrm>
           <a:prstGeom prst="rect">
             <a:avLst/>
@@ -4729,7 +4712,7 @@
           <a:p>
             <a:pPr algn="l"/>
             <a:r>
-              <a:rPr sz="1200" b="1">
+              <a:rPr sz="1400" b="1">
                 <a:solidFill>
                   <a:srgbClr val="FFFFFF"/>
                 </a:solidFill>
@@ -4779,6 +4762,7 @@
           <a:lstStyle/>
           <a:p>
             <a:pPr algn="ctr"/>
+            <a:endParaRPr sz="2000"/>
           </a:p>
         </p:txBody>
       </p:sp>
@@ -4791,7 +4775,7 @@
         <p:spPr>
           <a:xfrm>
             <a:off x="2743200" y="4379976"/>
-            <a:ext cx="2468879" cy="274320"/>
+            <a:ext cx="2468879" cy="307777"/>
           </a:xfrm>
           <a:prstGeom prst="rect">
             <a:avLst/>
@@ -4806,7 +4790,7 @@
           <a:p>
             <a:pPr algn="l"/>
             <a:r>
-              <a:rPr sz="1200" b="1">
+              <a:rPr sz="1400" b="1">
                 <a:solidFill>
                   <a:srgbClr val="FFFFFF"/>
                 </a:solidFill>
@@ -4856,6 +4840,7 @@
           <a:lstStyle/>
           <a:p>
             <a:pPr algn="ctr"/>
+            <a:endParaRPr sz="2000"/>
           </a:p>
         </p:txBody>
       </p:sp>
@@ -4868,7 +4853,7 @@
         <p:spPr>
           <a:xfrm>
             <a:off x="5394959" y="4379976"/>
-            <a:ext cx="4937760" cy="274320"/>
+            <a:ext cx="4937760" cy="307777"/>
           </a:xfrm>
           <a:prstGeom prst="rect">
             <a:avLst/>
@@ -4883,7 +4868,7 @@
           <a:p>
             <a:pPr algn="l"/>
             <a:r>
-              <a:rPr sz="1200" b="1">
+              <a:rPr sz="1400" b="1">
                 <a:solidFill>
                   <a:srgbClr val="FFFFFF"/>
                 </a:solidFill>
@@ -4933,6 +4918,7 @@
           <a:lstStyle/>
           <a:p>
             <a:pPr algn="ctr"/>
+            <a:endParaRPr sz="2000"/>
           </a:p>
         </p:txBody>
       </p:sp>
@@ -4960,7 +4946,7 @@
           <a:p>
             <a:pPr algn="l"/>
             <a:r>
-              <a:rPr sz="1100" b="0">
+              <a:rPr sz="1200" b="0">
                 <a:solidFill>
                   <a:srgbClr val="1A1A2E"/>
                 </a:solidFill>
@@ -5010,6 +4996,7 @@
           <a:lstStyle/>
           <a:p>
             <a:pPr algn="ctr"/>
+            <a:endParaRPr sz="2000"/>
           </a:p>
         </p:txBody>
       </p:sp>
@@ -5037,7 +5024,7 @@
           <a:p>
             <a:pPr algn="l"/>
             <a:r>
-              <a:rPr sz="1100" b="0">
+              <a:rPr sz="1200" b="0">
                 <a:solidFill>
                   <a:srgbClr val="1A1A2E"/>
                 </a:solidFill>
@@ -5087,6 +5074,7 @@
           <a:lstStyle/>
           <a:p>
             <a:pPr algn="ctr"/>
+            <a:endParaRPr sz="2000"/>
           </a:p>
         </p:txBody>
       </p:sp>
@@ -5114,7 +5102,7 @@
           <a:p>
             <a:pPr algn="l"/>
             <a:r>
-              <a:rPr sz="1100" b="0">
+              <a:rPr sz="1200" b="0">
                 <a:solidFill>
                   <a:srgbClr val="1A1A2E"/>
                 </a:solidFill>
@@ -5164,6 +5152,7 @@
           <a:lstStyle/>
           <a:p>
             <a:pPr algn="ctr"/>
+            <a:endParaRPr sz="2000"/>
           </a:p>
         </p:txBody>
       </p:sp>
@@ -5191,7 +5180,7 @@
           <a:p>
             <a:pPr algn="l"/>
             <a:r>
-              <a:rPr sz="1100" b="0">
+              <a:rPr sz="1200" b="0">
                 <a:solidFill>
                   <a:srgbClr val="1A1A2E"/>
                 </a:solidFill>
@@ -5241,6 +5230,7 @@
           <a:lstStyle/>
           <a:p>
             <a:pPr algn="ctr"/>
+            <a:endParaRPr sz="2000"/>
           </a:p>
         </p:txBody>
       </p:sp>
@@ -5268,7 +5258,7 @@
           <a:p>
             <a:pPr algn="l"/>
             <a:r>
-              <a:rPr sz="1100" b="0">
+              <a:rPr sz="1200" b="0">
                 <a:solidFill>
                   <a:srgbClr val="1A1A2E"/>
                 </a:solidFill>
@@ -5318,6 +5308,7 @@
           <a:lstStyle/>
           <a:p>
             <a:pPr algn="ctr"/>
+            <a:endParaRPr sz="2000"/>
           </a:p>
         </p:txBody>
       </p:sp>
@@ -5345,7 +5336,7 @@
           <a:p>
             <a:pPr algn="l"/>
             <a:r>
-              <a:rPr sz="1100" b="0">
+              <a:rPr sz="1200" b="0">
                 <a:solidFill>
                   <a:srgbClr val="1A1A2E"/>
                 </a:solidFill>
@@ -5395,6 +5386,7 @@
           <a:lstStyle/>
           <a:p>
             <a:pPr algn="ctr"/>
+            <a:endParaRPr sz="2000"/>
           </a:p>
         </p:txBody>
       </p:sp>
@@ -5422,7 +5414,7 @@
           <a:p>
             <a:pPr algn="l"/>
             <a:r>
-              <a:rPr sz="1100" b="0">
+              <a:rPr sz="1200" b="0">
                 <a:solidFill>
                   <a:srgbClr val="1A1A2E"/>
                 </a:solidFill>
@@ -5472,6 +5464,7 @@
           <a:lstStyle/>
           <a:p>
             <a:pPr algn="ctr"/>
+            <a:endParaRPr sz="2000"/>
           </a:p>
         </p:txBody>
       </p:sp>
@@ -5499,7 +5492,7 @@
           <a:p>
             <a:pPr algn="l"/>
             <a:r>
-              <a:rPr sz="1100" b="0">
+              <a:rPr sz="1200" b="0">
                 <a:solidFill>
                   <a:srgbClr val="1A1A2E"/>
                 </a:solidFill>
@@ -5549,6 +5542,7 @@
           <a:lstStyle/>
           <a:p>
             <a:pPr algn="ctr"/>
+            <a:endParaRPr sz="2000"/>
           </a:p>
         </p:txBody>
       </p:sp>
@@ -5576,7 +5570,7 @@
           <a:p>
             <a:pPr algn="l"/>
             <a:r>
-              <a:rPr sz="1100" b="0">
+              <a:rPr sz="1200" b="0">
                 <a:solidFill>
                   <a:srgbClr val="1A1A2E"/>
                 </a:solidFill>
@@ -5626,6 +5620,7 @@
           <a:lstStyle/>
           <a:p>
             <a:pPr algn="ctr"/>
+            <a:endParaRPr sz="2000"/>
           </a:p>
         </p:txBody>
       </p:sp>
@@ -5653,7 +5648,7 @@
           <a:p>
             <a:pPr algn="l"/>
             <a:r>
-              <a:rPr sz="1100" b="0">
+              <a:rPr sz="1200" b="0">
                 <a:solidFill>
                   <a:srgbClr val="1A1A2E"/>
                 </a:solidFill>
@@ -5703,6 +5698,7 @@
           <a:lstStyle/>
           <a:p>
             <a:pPr algn="ctr"/>
+            <a:endParaRPr sz="2000"/>
           </a:p>
         </p:txBody>
       </p:sp>
@@ -5730,7 +5726,7 @@
           <a:p>
             <a:pPr algn="l"/>
             <a:r>
-              <a:rPr sz="1100" b="0">
+              <a:rPr sz="1200" b="0">
                 <a:solidFill>
                   <a:srgbClr val="1A1A2E"/>
                 </a:solidFill>
@@ -5780,6 +5776,7 @@
           <a:lstStyle/>
           <a:p>
             <a:pPr algn="ctr"/>
+            <a:endParaRPr sz="2000"/>
           </a:p>
         </p:txBody>
       </p:sp>
@@ -5807,7 +5804,7 @@
           <a:p>
             <a:pPr algn="l"/>
             <a:r>
-              <a:rPr sz="1100" b="0">
+              <a:rPr sz="1200" b="0">
                 <a:solidFill>
                   <a:srgbClr val="1A1A2E"/>
                 </a:solidFill>
@@ -5826,7 +5823,7 @@
 </file>
 
 <file path=ppt/slides/slide4.xml><?xml version="1.0" encoding="utf-8"?>
-<p:sld xmlns:a="http://schemas.openxmlformats.org/drawingml/2006/main" xmlns:p="http://schemas.openxmlformats.org/presentationml/2006/main" xmlns:r="http://schemas.openxmlformats.org/officeDocument/2006/relationships">
+<p:sld xmlns:a="http://schemas.openxmlformats.org/drawingml/2006/main" xmlns:r="http://schemas.openxmlformats.org/officeDocument/2006/relationships" xmlns:p="http://schemas.openxmlformats.org/presentationml/2006/main">
   <p:cSld>
     <p:spTree>
       <p:nvGrpSpPr>
@@ -5834,7 +5831,14 @@
         <p:cNvGrpSpPr/>
         <p:nvPr/>
       </p:nvGrpSpPr>
-      <p:grpSpPr/>
+      <p:grpSpPr>
+        <a:xfrm>
+          <a:off x="0" y="0"/>
+          <a:ext cx="0" cy="0"/>
+          <a:chOff x="0" y="0"/>
+          <a:chExt cx="0" cy="0"/>
+        </a:xfrm>
+      </p:grpSpPr>
       <p:sp>
         <p:nvSpPr>
           <p:cNvPr id="2" name="Rectangle 1"/>
@@ -5875,6 +5879,7 @@
           <a:lstStyle/>
           <a:p>
             <a:pPr algn="ctr"/>
+            <a:endParaRPr/>
           </a:p>
         </p:txBody>
       </p:sp>
@@ -5918,6 +5923,7 @@
           <a:lstStyle/>
           <a:p>
             <a:pPr algn="ctr"/>
+            <a:endParaRPr/>
           </a:p>
         </p:txBody>
       </p:sp>
@@ -6142,6 +6148,7 @@
           <a:lstStyle/>
           <a:p>
             <a:pPr algn="ctr"/>
+            <a:endParaRPr/>
           </a:p>
         </p:txBody>
       </p:sp>
@@ -6219,6 +6226,7 @@
           <a:lstStyle/>
           <a:p>
             <a:pPr algn="ctr"/>
+            <a:endParaRPr/>
           </a:p>
         </p:txBody>
       </p:sp>
@@ -6296,6 +6304,7 @@
           <a:lstStyle/>
           <a:p>
             <a:pPr algn="ctr"/>
+            <a:endParaRPr/>
           </a:p>
         </p:txBody>
       </p:sp>
@@ -6373,6 +6382,7 @@
           <a:lstStyle/>
           <a:p>
             <a:pPr algn="ctr"/>
+            <a:endParaRPr/>
           </a:p>
         </p:txBody>
       </p:sp>
@@ -6450,6 +6460,7 @@
           <a:lstStyle/>
           <a:p>
             <a:pPr algn="ctr"/>
+            <a:endParaRPr/>
           </a:p>
         </p:txBody>
       </p:sp>
@@ -6527,6 +6538,7 @@
           <a:lstStyle/>
           <a:p>
             <a:pPr algn="ctr"/>
+            <a:endParaRPr/>
           </a:p>
         </p:txBody>
       </p:sp>
@@ -6604,6 +6616,7 @@
           <a:lstStyle/>
           <a:p>
             <a:pPr algn="ctr"/>
+            <a:endParaRPr/>
           </a:p>
         </p:txBody>
       </p:sp>
@@ -6681,6 +6694,7 @@
           <a:lstStyle/>
           <a:p>
             <a:pPr algn="ctr"/>
+            <a:endParaRPr/>
           </a:p>
         </p:txBody>
       </p:sp>
@@ -6758,6 +6772,7 @@
           <a:lstStyle/>
           <a:p>
             <a:pPr algn="ctr"/>
+            <a:endParaRPr/>
           </a:p>
         </p:txBody>
       </p:sp>
@@ -6835,6 +6850,7 @@
           <a:lstStyle/>
           <a:p>
             <a:pPr algn="ctr"/>
+            <a:endParaRPr/>
           </a:p>
         </p:txBody>
       </p:sp>
@@ -6912,6 +6928,7 @@
           <a:lstStyle/>
           <a:p>
             <a:pPr algn="ctr"/>
+            <a:endParaRPr/>
           </a:p>
         </p:txBody>
       </p:sp>
@@ -6989,6 +7006,7 @@
           <a:lstStyle/>
           <a:p>
             <a:pPr algn="ctr"/>
+            <a:endParaRPr/>
           </a:p>
         </p:txBody>
       </p:sp>
@@ -7066,6 +7084,7 @@
           <a:lstStyle/>
           <a:p>
             <a:pPr algn="ctr"/>
+            <a:endParaRPr/>
           </a:p>
         </p:txBody>
       </p:sp>
@@ -7143,6 +7162,7 @@
           <a:lstStyle/>
           <a:p>
             <a:pPr algn="ctr"/>
+            <a:endParaRPr/>
           </a:p>
         </p:txBody>
       </p:sp>
@@ -7220,6 +7240,7 @@
           <a:lstStyle/>
           <a:p>
             <a:pPr algn="ctr"/>
+            <a:endParaRPr/>
           </a:p>
         </p:txBody>
       </p:sp>
@@ -7297,6 +7318,7 @@
           <a:lstStyle/>
           <a:p>
             <a:pPr algn="ctr"/>
+            <a:endParaRPr/>
           </a:p>
         </p:txBody>
       </p:sp>
@@ -7374,6 +7396,7 @@
           <a:lstStyle/>
           <a:p>
             <a:pPr algn="ctr"/>
+            <a:endParaRPr/>
           </a:p>
         </p:txBody>
       </p:sp>
@@ -7451,6 +7474,7 @@
           <a:lstStyle/>
           <a:p>
             <a:pPr algn="ctr"/>
+            <a:endParaRPr/>
           </a:p>
         </p:txBody>
       </p:sp>
@@ -7528,6 +7552,7 @@
           <a:lstStyle/>
           <a:p>
             <a:pPr algn="ctr"/>
+            <a:endParaRPr/>
           </a:p>
         </p:txBody>
       </p:sp>
@@ -7605,6 +7630,7 @@
           <a:lstStyle/>
           <a:p>
             <a:pPr algn="ctr"/>
+            <a:endParaRPr/>
           </a:p>
         </p:txBody>
       </p:sp>
@@ -7829,6 +7855,7 @@
           <a:lstStyle/>
           <a:p>
             <a:pPr algn="ctr"/>
+            <a:endParaRPr/>
           </a:p>
         </p:txBody>
       </p:sp>
@@ -7876,7 +7903,7 @@
 </file>
 
 <file path=ppt/slides/slide5.xml><?xml version="1.0" encoding="utf-8"?>
-<p:sld xmlns:a="http://schemas.openxmlformats.org/drawingml/2006/main" xmlns:p="http://schemas.openxmlformats.org/presentationml/2006/main" xmlns:r="http://schemas.openxmlformats.org/officeDocument/2006/relationships">
+<p:sld xmlns:a="http://schemas.openxmlformats.org/drawingml/2006/main" xmlns:r="http://schemas.openxmlformats.org/officeDocument/2006/relationships" xmlns:p="http://schemas.openxmlformats.org/presentationml/2006/main">
   <p:cSld>
     <p:spTree>
       <p:nvGrpSpPr>
@@ -7884,7 +7911,14 @@
         <p:cNvGrpSpPr/>
         <p:nvPr/>
       </p:nvGrpSpPr>
-      <p:grpSpPr/>
+      <p:grpSpPr>
+        <a:xfrm>
+          <a:off x="0" y="0"/>
+          <a:ext cx="0" cy="0"/>
+          <a:chOff x="0" y="0"/>
+          <a:chExt cx="0" cy="0"/>
+        </a:xfrm>
+      </p:grpSpPr>
       <p:sp>
         <p:nvSpPr>
           <p:cNvPr id="2" name="Rectangle 1"/>
@@ -7925,6 +7959,7 @@
           <a:lstStyle/>
           <a:p>
             <a:pPr algn="ctr"/>
+            <a:endParaRPr sz="2000"/>
           </a:p>
         </p:txBody>
       </p:sp>
@@ -7968,6 +8003,7 @@
           <a:lstStyle/>
           <a:p>
             <a:pPr algn="ctr"/>
+            <a:endParaRPr sz="2000"/>
           </a:p>
         </p:txBody>
       </p:sp>
@@ -7980,7 +8016,7 @@
         <p:spPr>
           <a:xfrm>
             <a:off x="274320" y="137160"/>
-            <a:ext cx="10972800" cy="731520"/>
+            <a:ext cx="10972800" cy="584775"/>
           </a:xfrm>
           <a:prstGeom prst="rect">
             <a:avLst/>
@@ -7995,7 +8031,7 @@
           <a:p>
             <a:pPr algn="l"/>
             <a:r>
-              <a:rPr sz="2800" b="1">
+              <a:rPr sz="3200" b="1">
                 <a:solidFill>
                   <a:srgbClr val="FFFFFF"/>
                 </a:solidFill>
@@ -8029,7 +8065,7 @@
           <a:p>
             <a:pPr algn="l"/>
             <a:r>
-              <a:rPr sz="1600" b="1">
+              <a:rPr b="1">
                 <a:solidFill>
                   <a:srgbClr val="2E75B6"/>
                 </a:solidFill>
@@ -8079,6 +8115,7 @@
           <a:lstStyle/>
           <a:p>
             <a:pPr algn="ctr"/>
+            <a:endParaRPr sz="2000"/>
           </a:p>
         </p:txBody>
       </p:sp>
@@ -8091,7 +8128,7 @@
         <p:spPr>
           <a:xfrm>
             <a:off x="411480" y="1728216"/>
-            <a:ext cx="2194560" cy="292608"/>
+            <a:ext cx="2194560" cy="307777"/>
           </a:xfrm>
           <a:prstGeom prst="rect">
             <a:avLst/>
@@ -8106,7 +8143,7 @@
           <a:p>
             <a:pPr algn="l"/>
             <a:r>
-              <a:rPr sz="1200" b="1">
+              <a:rPr sz="1400" b="1">
                 <a:solidFill>
                   <a:srgbClr val="FFFFFF"/>
                 </a:solidFill>
@@ -8156,6 +8193,7 @@
           <a:lstStyle/>
           <a:p>
             <a:pPr algn="ctr"/>
+            <a:endParaRPr sz="2000"/>
           </a:p>
         </p:txBody>
       </p:sp>
@@ -8168,7 +8206,7 @@
         <p:spPr>
           <a:xfrm>
             <a:off x="2697480" y="1728216"/>
-            <a:ext cx="3108960" cy="292608"/>
+            <a:ext cx="3108960" cy="307777"/>
           </a:xfrm>
           <a:prstGeom prst="rect">
             <a:avLst/>
@@ -8183,7 +8221,7 @@
           <a:p>
             <a:pPr algn="l"/>
             <a:r>
-              <a:rPr sz="1200" b="0">
+              <a:rPr sz="1400" b="0">
                 <a:solidFill>
                   <a:srgbClr val="1A1A2E"/>
                 </a:solidFill>
@@ -8233,6 +8271,7 @@
           <a:lstStyle/>
           <a:p>
             <a:pPr algn="ctr"/>
+            <a:endParaRPr sz="2000"/>
           </a:p>
         </p:txBody>
       </p:sp>
@@ -8245,7 +8284,7 @@
         <p:spPr>
           <a:xfrm>
             <a:off x="411480" y="2139696"/>
-            <a:ext cx="2194560" cy="292608"/>
+            <a:ext cx="2194560" cy="307777"/>
           </a:xfrm>
           <a:prstGeom prst="rect">
             <a:avLst/>
@@ -8260,7 +8299,7 @@
           <a:p>
             <a:pPr algn="l"/>
             <a:r>
-              <a:rPr sz="1200" b="1">
+              <a:rPr sz="1400" b="1">
                 <a:solidFill>
                   <a:srgbClr val="FFFFFF"/>
                 </a:solidFill>
@@ -8310,6 +8349,7 @@
           <a:lstStyle/>
           <a:p>
             <a:pPr algn="ctr"/>
+            <a:endParaRPr sz="2000"/>
           </a:p>
         </p:txBody>
       </p:sp>
@@ -8322,7 +8362,7 @@
         <p:spPr>
           <a:xfrm>
             <a:off x="2697480" y="2139696"/>
-            <a:ext cx="3108960" cy="292608"/>
+            <a:ext cx="3108960" cy="307777"/>
           </a:xfrm>
           <a:prstGeom prst="rect">
             <a:avLst/>
@@ -8337,7 +8377,7 @@
           <a:p>
             <a:pPr algn="l"/>
             <a:r>
-              <a:rPr sz="1200" b="0">
+              <a:rPr sz="1400" b="0">
                 <a:solidFill>
                   <a:srgbClr val="1A1A2E"/>
                 </a:solidFill>
@@ -8387,6 +8427,7 @@
           <a:lstStyle/>
           <a:p>
             <a:pPr algn="ctr"/>
+            <a:endParaRPr sz="2000"/>
           </a:p>
         </p:txBody>
       </p:sp>
@@ -8399,7 +8440,7 @@
         <p:spPr>
           <a:xfrm>
             <a:off x="411480" y="2551176"/>
-            <a:ext cx="2194560" cy="292608"/>
+            <a:ext cx="2194560" cy="307777"/>
           </a:xfrm>
           <a:prstGeom prst="rect">
             <a:avLst/>
@@ -8414,7 +8455,7 @@
           <a:p>
             <a:pPr algn="l"/>
             <a:r>
-              <a:rPr sz="1200" b="1">
+              <a:rPr sz="1400" b="1">
                 <a:solidFill>
                   <a:srgbClr val="FFFFFF"/>
                 </a:solidFill>
@@ -8464,6 +8505,7 @@
           <a:lstStyle/>
           <a:p>
             <a:pPr algn="ctr"/>
+            <a:endParaRPr sz="2000"/>
           </a:p>
         </p:txBody>
       </p:sp>
@@ -8476,7 +8518,7 @@
         <p:spPr>
           <a:xfrm>
             <a:off x="2697480" y="2551176"/>
-            <a:ext cx="3108960" cy="292608"/>
+            <a:ext cx="3108960" cy="523220"/>
           </a:xfrm>
           <a:prstGeom prst="rect">
             <a:avLst/>
@@ -8491,7 +8533,7 @@
           <a:p>
             <a:pPr algn="l"/>
             <a:r>
-              <a:rPr sz="1200" b="0">
+              <a:rPr sz="1400" b="0">
                 <a:solidFill>
                   <a:srgbClr val="1A1A2E"/>
                 </a:solidFill>
@@ -8541,6 +8583,7 @@
           <a:lstStyle/>
           <a:p>
             <a:pPr algn="ctr"/>
+            <a:endParaRPr sz="2000"/>
           </a:p>
         </p:txBody>
       </p:sp>
@@ -8553,7 +8596,7 @@
         <p:spPr>
           <a:xfrm>
             <a:off x="411480" y="2962656"/>
-            <a:ext cx="2194560" cy="292608"/>
+            <a:ext cx="2194560" cy="307777"/>
           </a:xfrm>
           <a:prstGeom prst="rect">
             <a:avLst/>
@@ -8568,7 +8611,7 @@
           <a:p>
             <a:pPr algn="l"/>
             <a:r>
-              <a:rPr sz="1200" b="1">
+              <a:rPr sz="1400" b="1">
                 <a:solidFill>
                   <a:srgbClr val="FFFFFF"/>
                 </a:solidFill>
@@ -8618,6 +8661,7 @@
           <a:lstStyle/>
           <a:p>
             <a:pPr algn="ctr"/>
+            <a:endParaRPr sz="2000"/>
           </a:p>
         </p:txBody>
       </p:sp>
@@ -8630,7 +8674,7 @@
         <p:spPr>
           <a:xfrm>
             <a:off x="2697480" y="2962656"/>
-            <a:ext cx="3108960" cy="292608"/>
+            <a:ext cx="3108960" cy="307777"/>
           </a:xfrm>
           <a:prstGeom prst="rect">
             <a:avLst/>
@@ -8645,7 +8689,7 @@
           <a:p>
             <a:pPr algn="l"/>
             <a:r>
-              <a:rPr sz="1200" b="0">
+              <a:rPr sz="1400" b="0">
                 <a:solidFill>
                   <a:srgbClr val="1A1A2E"/>
                 </a:solidFill>
@@ -8679,7 +8723,7 @@
           <a:p>
             <a:pPr algn="l"/>
             <a:r>
-              <a:rPr sz="1600" b="1">
+              <a:rPr b="1">
                 <a:solidFill>
                   <a:srgbClr val="2E75B6"/>
                 </a:solidFill>
@@ -8698,7 +8742,7 @@
         <p:spPr>
           <a:xfrm>
             <a:off x="365760" y="4069080"/>
-            <a:ext cx="5486400" cy="2286000"/>
+            <a:ext cx="5486400" cy="1631216"/>
           </a:xfrm>
           <a:prstGeom prst="rect">
             <a:avLst/>
@@ -8717,7 +8761,7 @@
               </a:spcAft>
             </a:pPr>
             <a:r>
-              <a:rPr sz="1400">
+              <a:rPr sz="1600">
                 <a:solidFill>
                   <a:srgbClr val="1A1A2E"/>
                 </a:solidFill>
@@ -8732,7 +8776,7 @@
               </a:spcAft>
             </a:pPr>
             <a:r>
-              <a:rPr sz="1400">
+              <a:rPr sz="1600">
                 <a:solidFill>
                   <a:srgbClr val="1A1A2E"/>
                 </a:solidFill>
@@ -8747,7 +8791,7 @@
               </a:spcAft>
             </a:pPr>
             <a:r>
-              <a:rPr sz="1400">
+              <a:rPr sz="1600">
                 <a:solidFill>
                   <a:srgbClr val="1A1A2E"/>
                 </a:solidFill>
@@ -8762,7 +8806,7 @@
               </a:spcAft>
             </a:pPr>
             <a:r>
-              <a:rPr sz="1400">
+              <a:rPr sz="1600">
                 <a:solidFill>
                   <a:srgbClr val="1A1A2E"/>
                 </a:solidFill>
@@ -8777,7 +8821,7 @@
               </a:spcAft>
             </a:pPr>
             <a:r>
-              <a:rPr sz="1400">
+              <a:rPr sz="1600">
                 <a:solidFill>
                   <a:srgbClr val="1A1A2E"/>
                 </a:solidFill>
@@ -8811,7 +8855,7 @@
           <a:p>
             <a:pPr algn="l"/>
             <a:r>
-              <a:rPr sz="1600" b="1">
+              <a:rPr b="1">
                 <a:solidFill>
                   <a:srgbClr val="2E75B6"/>
                 </a:solidFill>
@@ -8830,7 +8874,7 @@
         <p:spPr>
           <a:xfrm>
             <a:off x="6400800" y="1691640"/>
-            <a:ext cx="5486400" cy="2743200"/>
+            <a:ext cx="5486400" cy="2123658"/>
           </a:xfrm>
           <a:prstGeom prst="rect">
             <a:avLst/>
@@ -8849,7 +8893,7 @@
               </a:spcAft>
             </a:pPr>
             <a:r>
-              <a:rPr sz="1400">
+              <a:rPr sz="1600">
                 <a:solidFill>
                   <a:srgbClr val="1A1A2E"/>
                 </a:solidFill>
@@ -8864,7 +8908,7 @@
               </a:spcAft>
             </a:pPr>
             <a:r>
-              <a:rPr sz="1400">
+              <a:rPr sz="1600">
                 <a:solidFill>
                   <a:srgbClr val="1A1A2E"/>
                 </a:solidFill>
@@ -8879,7 +8923,7 @@
               </a:spcAft>
             </a:pPr>
             <a:r>
-              <a:rPr sz="1400">
+              <a:rPr sz="1600">
                 <a:solidFill>
                   <a:srgbClr val="1A1A2E"/>
                 </a:solidFill>
@@ -8894,7 +8938,7 @@
               </a:spcAft>
             </a:pPr>
             <a:r>
-              <a:rPr sz="1400">
+              <a:rPr sz="1600">
                 <a:solidFill>
                   <a:srgbClr val="1A1A2E"/>
                 </a:solidFill>
@@ -8909,7 +8953,7 @@
               </a:spcAft>
             </a:pPr>
             <a:r>
-              <a:rPr sz="1400">
+              <a:rPr sz="1600">
                 <a:solidFill>
                   <a:srgbClr val="1A1A2E"/>
                 </a:solidFill>
@@ -8943,7 +8987,7 @@
           <a:p>
             <a:pPr algn="l"/>
             <a:r>
-              <a:rPr sz="1600" b="1">
+              <a:rPr b="1">
                 <a:solidFill>
                   <a:srgbClr val="2E75B6"/>
                 </a:solidFill>
@@ -8962,7 +9006,7 @@
         <p:spPr>
           <a:xfrm>
             <a:off x="6400800" y="4983480"/>
-            <a:ext cx="5486400" cy="1554480"/>
+            <a:ext cx="5486400" cy="984885"/>
           </a:xfrm>
           <a:prstGeom prst="rect">
             <a:avLst/>
@@ -8981,7 +9025,7 @@
               </a:spcAft>
             </a:pPr>
             <a:r>
-              <a:rPr sz="1400">
+              <a:rPr sz="1600">
                 <a:solidFill>
                   <a:srgbClr val="1A1A2E"/>
                 </a:solidFill>
@@ -8996,7 +9040,7 @@
               </a:spcAft>
             </a:pPr>
             <a:r>
-              <a:rPr sz="1400">
+              <a:rPr sz="1600">
                 <a:solidFill>
                   <a:srgbClr val="1A1A2E"/>
                 </a:solidFill>
@@ -9011,7 +9055,7 @@
               </a:spcAft>
             </a:pPr>
             <a:r>
-              <a:rPr sz="1400">
+              <a:rPr sz="1600">
                 <a:solidFill>
                   <a:srgbClr val="1A1A2E"/>
                 </a:solidFill>
@@ -9030,7 +9074,7 @@
 </file>
 
 <file path=ppt/slides/slide6.xml><?xml version="1.0" encoding="utf-8"?>
-<p:sld xmlns:a="http://schemas.openxmlformats.org/drawingml/2006/main" xmlns:p="http://schemas.openxmlformats.org/presentationml/2006/main" xmlns:r="http://schemas.openxmlformats.org/officeDocument/2006/relationships">
+<p:sld xmlns:a="http://schemas.openxmlformats.org/drawingml/2006/main" xmlns:r="http://schemas.openxmlformats.org/officeDocument/2006/relationships" xmlns:p="http://schemas.openxmlformats.org/presentationml/2006/main">
   <p:cSld>
     <p:spTree>
       <p:nvGrpSpPr>
@@ -9038,7 +9082,14 @@
         <p:cNvGrpSpPr/>
         <p:nvPr/>
       </p:nvGrpSpPr>
-      <p:grpSpPr/>
+      <p:grpSpPr>
+        <a:xfrm>
+          <a:off x="0" y="0"/>
+          <a:ext cx="0" cy="0"/>
+          <a:chOff x="0" y="0"/>
+          <a:chExt cx="0" cy="0"/>
+        </a:xfrm>
+      </p:grpSpPr>
       <p:sp>
         <p:nvSpPr>
           <p:cNvPr id="2" name="Rectangle 1"/>
@@ -9079,6 +9130,7 @@
           <a:lstStyle/>
           <a:p>
             <a:pPr algn="ctr"/>
+            <a:endParaRPr sz="2000"/>
           </a:p>
         </p:txBody>
       </p:sp>
@@ -9122,6 +9174,7 @@
           <a:lstStyle/>
           <a:p>
             <a:pPr algn="ctr"/>
+            <a:endParaRPr sz="2000"/>
           </a:p>
         </p:txBody>
       </p:sp>
@@ -9134,7 +9187,7 @@
         <p:spPr>
           <a:xfrm>
             <a:off x="274320" y="137160"/>
-            <a:ext cx="10972800" cy="731520"/>
+            <a:ext cx="10972800" cy="584775"/>
           </a:xfrm>
           <a:prstGeom prst="rect">
             <a:avLst/>
@@ -9149,7 +9202,7 @@
           <a:p>
             <a:pPr algn="l"/>
             <a:r>
-              <a:rPr sz="2800" b="1">
+              <a:rPr sz="3200" b="1">
                 <a:solidFill>
                   <a:srgbClr val="FFFFFF"/>
                 </a:solidFill>
@@ -9183,7 +9236,7 @@
           <a:p>
             <a:pPr algn="l"/>
             <a:r>
-              <a:rPr sz="1700" b="1">
+              <a:rPr b="1">
                 <a:solidFill>
                   <a:srgbClr val="2E75B6"/>
                 </a:solidFill>
@@ -9202,7 +9255,7 @@
         <p:spPr>
           <a:xfrm>
             <a:off x="365760" y="1664208"/>
-            <a:ext cx="5394960" cy="2743200"/>
+            <a:ext cx="5394960" cy="1954381"/>
           </a:xfrm>
           <a:prstGeom prst="rect">
             <a:avLst/>
@@ -9221,7 +9274,7 @@
               </a:spcAft>
             </a:pPr>
             <a:r>
-              <a:rPr sz="1400">
+              <a:rPr sz="1600">
                 <a:solidFill>
                   <a:srgbClr val="1A1A2E"/>
                 </a:solidFill>
@@ -9236,7 +9289,7 @@
               </a:spcAft>
             </a:pPr>
             <a:r>
-              <a:rPr sz="1400">
+              <a:rPr sz="1600">
                 <a:solidFill>
                   <a:srgbClr val="1A1A2E"/>
                 </a:solidFill>
@@ -9251,7 +9304,7 @@
               </a:spcAft>
             </a:pPr>
             <a:r>
-              <a:rPr sz="1400">
+              <a:rPr sz="1600">
                 <a:solidFill>
                   <a:srgbClr val="1A1A2E"/>
                 </a:solidFill>
@@ -9266,7 +9319,7 @@
               </a:spcAft>
             </a:pPr>
             <a:r>
-              <a:rPr sz="1400">
+              <a:rPr sz="1600">
                 <a:solidFill>
                   <a:srgbClr val="1A1A2E"/>
                 </a:solidFill>
@@ -9281,7 +9334,7 @@
               </a:spcAft>
             </a:pPr>
             <a:r>
-              <a:rPr sz="1400">
+              <a:rPr sz="1600">
                 <a:solidFill>
                   <a:srgbClr val="1A1A2E"/>
                 </a:solidFill>
@@ -9296,7 +9349,7 @@
               </a:spcAft>
             </a:pPr>
             <a:r>
-              <a:rPr sz="1400">
+              <a:rPr sz="1600">
                 <a:solidFill>
                   <a:srgbClr val="1A1A2E"/>
                 </a:solidFill>
@@ -9315,7 +9368,7 @@
         <p:spPr>
           <a:xfrm>
             <a:off x="365760" y="4572000"/>
-            <a:ext cx="5486400" cy="365760"/>
+            <a:ext cx="5486400" cy="338554"/>
           </a:xfrm>
           <a:prstGeom prst="rect">
             <a:avLst/>
@@ -9330,7 +9383,7 @@
           <a:p>
             <a:pPr algn="l"/>
             <a:r>
-              <a:rPr sz="1500" b="1">
+              <a:rPr sz="1600" b="1">
                 <a:solidFill>
                   <a:srgbClr val="2E75B6"/>
                 </a:solidFill>
@@ -9349,7 +9402,7 @@
         <p:spPr>
           <a:xfrm>
             <a:off x="365760" y="4983480"/>
-            <a:ext cx="5486400" cy="1097280"/>
+            <a:ext cx="5486400" cy="661720"/>
           </a:xfrm>
           <a:prstGeom prst="rect">
             <a:avLst/>
@@ -9368,7 +9421,7 @@
               </a:spcAft>
             </a:pPr>
             <a:r>
-              <a:rPr sz="1400">
+              <a:rPr sz="1600">
                 <a:solidFill>
                   <a:srgbClr val="1A1A2E"/>
                 </a:solidFill>
@@ -9383,7 +9436,7 @@
               </a:spcAft>
             </a:pPr>
             <a:r>
-              <a:rPr sz="1400">
+              <a:rPr sz="1600">
                 <a:solidFill>
                   <a:srgbClr val="1A1A2E"/>
                 </a:solidFill>
@@ -9417,7 +9470,7 @@
           <a:p>
             <a:pPr algn="l"/>
             <a:r>
-              <a:rPr sz="1700" b="1">
+              <a:rPr b="1">
                 <a:solidFill>
                   <a:srgbClr val="2E75B6"/>
                 </a:solidFill>
@@ -9467,6 +9520,7 @@
           <a:lstStyle/>
           <a:p>
             <a:pPr algn="ctr"/>
+            <a:endParaRPr sz="2000"/>
           </a:p>
         </p:txBody>
       </p:sp>
@@ -9479,7 +9533,7 @@
         <p:spPr>
           <a:xfrm>
             <a:off x="6437376" y="1737360"/>
-            <a:ext cx="749808" cy="329184"/>
+            <a:ext cx="749808" cy="307777"/>
           </a:xfrm>
           <a:prstGeom prst="rect">
             <a:avLst/>
@@ -9494,7 +9548,7 @@
           <a:p>
             <a:pPr algn="l"/>
             <a:r>
-              <a:rPr sz="1300" b="1">
+              <a:rPr sz="1400" b="1">
                 <a:solidFill>
                   <a:srgbClr val="1A1A2E"/>
                 </a:solidFill>
@@ -9544,6 +9598,7 @@
           <a:lstStyle/>
           <a:p>
             <a:pPr algn="ctr"/>
+            <a:endParaRPr sz="2000"/>
           </a:p>
         </p:txBody>
       </p:sp>
@@ -9556,7 +9611,7 @@
         <p:spPr>
           <a:xfrm>
             <a:off x="7351775" y="1737360"/>
-            <a:ext cx="2761488" cy="329184"/>
+            <a:ext cx="2761488" cy="307777"/>
           </a:xfrm>
           <a:prstGeom prst="rect">
             <a:avLst/>
@@ -9571,7 +9626,7 @@
           <a:p>
             <a:pPr algn="l"/>
             <a:r>
-              <a:rPr sz="1300" b="0">
+              <a:rPr sz="1400" b="0">
                 <a:solidFill>
                   <a:srgbClr val="1A1A2E"/>
                 </a:solidFill>
@@ -9621,6 +9676,7 @@
           <a:lstStyle/>
           <a:p>
             <a:pPr algn="ctr"/>
+            <a:endParaRPr sz="2000"/>
           </a:p>
         </p:txBody>
       </p:sp>
@@ -9633,7 +9689,7 @@
         <p:spPr>
           <a:xfrm>
             <a:off x="10277855" y="1737360"/>
-            <a:ext cx="1298448" cy="329184"/>
+            <a:ext cx="1298448" cy="307777"/>
           </a:xfrm>
           <a:prstGeom prst="rect">
             <a:avLst/>
@@ -9648,7 +9704,7 @@
           <a:p>
             <a:pPr algn="l"/>
             <a:r>
-              <a:rPr sz="1300" b="0">
+              <a:rPr sz="1400" b="0">
                 <a:solidFill>
                   <a:srgbClr val="1A1A2E"/>
                 </a:solidFill>
@@ -9698,6 +9754,7 @@
           <a:lstStyle/>
           <a:p>
             <a:pPr algn="ctr"/>
+            <a:endParaRPr sz="2000"/>
           </a:p>
         </p:txBody>
       </p:sp>
@@ -9710,7 +9767,7 @@
         <p:spPr>
           <a:xfrm>
             <a:off x="6437376" y="2194560"/>
-            <a:ext cx="749808" cy="329184"/>
+            <a:ext cx="749808" cy="307777"/>
           </a:xfrm>
           <a:prstGeom prst="rect">
             <a:avLst/>
@@ -9725,7 +9782,7 @@
           <a:p>
             <a:pPr algn="l"/>
             <a:r>
-              <a:rPr sz="1300" b="1">
+              <a:rPr sz="1400" b="1">
                 <a:solidFill>
                   <a:srgbClr val="1A1A2E"/>
                 </a:solidFill>
@@ -9775,6 +9832,7 @@
           <a:lstStyle/>
           <a:p>
             <a:pPr algn="ctr"/>
+            <a:endParaRPr sz="2000"/>
           </a:p>
         </p:txBody>
       </p:sp>
@@ -9787,7 +9845,7 @@
         <p:spPr>
           <a:xfrm>
             <a:off x="7351775" y="2194560"/>
-            <a:ext cx="2761488" cy="329184"/>
+            <a:ext cx="2761488" cy="307777"/>
           </a:xfrm>
           <a:prstGeom prst="rect">
             <a:avLst/>
@@ -9802,7 +9860,7 @@
           <a:p>
             <a:pPr algn="l"/>
             <a:r>
-              <a:rPr sz="1300" b="0">
+              <a:rPr sz="1400" b="0">
                 <a:solidFill>
                   <a:srgbClr val="1A1A2E"/>
                 </a:solidFill>
@@ -9852,6 +9910,7 @@
           <a:lstStyle/>
           <a:p>
             <a:pPr algn="ctr"/>
+            <a:endParaRPr sz="2000"/>
           </a:p>
         </p:txBody>
       </p:sp>
@@ -9864,7 +9923,7 @@
         <p:spPr>
           <a:xfrm>
             <a:off x="10277855" y="2194560"/>
-            <a:ext cx="1298448" cy="329184"/>
+            <a:ext cx="1298448" cy="307777"/>
           </a:xfrm>
           <a:prstGeom prst="rect">
             <a:avLst/>
@@ -9879,7 +9938,7 @@
           <a:p>
             <a:pPr algn="l"/>
             <a:r>
-              <a:rPr sz="1300" b="0">
+              <a:rPr sz="1400" b="0">
                 <a:solidFill>
                   <a:srgbClr val="1A1A2E"/>
                 </a:solidFill>
@@ -9929,6 +9988,7 @@
           <a:lstStyle/>
           <a:p>
             <a:pPr algn="ctr"/>
+            <a:endParaRPr sz="2000"/>
           </a:p>
         </p:txBody>
       </p:sp>
@@ -9941,7 +10001,7 @@
         <p:spPr>
           <a:xfrm>
             <a:off x="6437376" y="2651760"/>
-            <a:ext cx="749808" cy="329184"/>
+            <a:ext cx="749808" cy="307777"/>
           </a:xfrm>
           <a:prstGeom prst="rect">
             <a:avLst/>
@@ -9956,7 +10016,7 @@
           <a:p>
             <a:pPr algn="l"/>
             <a:r>
-              <a:rPr sz="1300" b="1">
+              <a:rPr sz="1400" b="1">
                 <a:solidFill>
                   <a:srgbClr val="1A1A2E"/>
                 </a:solidFill>
@@ -10006,6 +10066,7 @@
           <a:lstStyle/>
           <a:p>
             <a:pPr algn="ctr"/>
+            <a:endParaRPr sz="2000"/>
           </a:p>
         </p:txBody>
       </p:sp>
@@ -10018,7 +10079,7 @@
         <p:spPr>
           <a:xfrm>
             <a:off x="7351775" y="2651760"/>
-            <a:ext cx="2761488" cy="329184"/>
+            <a:ext cx="2761488" cy="307777"/>
           </a:xfrm>
           <a:prstGeom prst="rect">
             <a:avLst/>
@@ -10033,7 +10094,7 @@
           <a:p>
             <a:pPr algn="l"/>
             <a:r>
-              <a:rPr sz="1300" b="0">
+              <a:rPr sz="1400" b="0">
                 <a:solidFill>
                   <a:srgbClr val="1A1A2E"/>
                 </a:solidFill>
@@ -10083,6 +10144,7 @@
           <a:lstStyle/>
           <a:p>
             <a:pPr algn="ctr"/>
+            <a:endParaRPr sz="2000"/>
           </a:p>
         </p:txBody>
       </p:sp>
@@ -10095,7 +10157,7 @@
         <p:spPr>
           <a:xfrm>
             <a:off x="10277855" y="2651760"/>
-            <a:ext cx="1298448" cy="329184"/>
+            <a:ext cx="1298448" cy="307777"/>
           </a:xfrm>
           <a:prstGeom prst="rect">
             <a:avLst/>
@@ -10110,7 +10172,7 @@
           <a:p>
             <a:pPr algn="l"/>
             <a:r>
-              <a:rPr sz="1300" b="0">
+              <a:rPr sz="1400" b="0">
                 <a:solidFill>
                   <a:srgbClr val="1A1A2E"/>
                 </a:solidFill>
@@ -10160,6 +10222,7 @@
           <a:lstStyle/>
           <a:p>
             <a:pPr algn="ctr"/>
+            <a:endParaRPr sz="2000"/>
           </a:p>
         </p:txBody>
       </p:sp>
@@ -10172,7 +10235,7 @@
         <p:spPr>
           <a:xfrm>
             <a:off x="6437376" y="3108960"/>
-            <a:ext cx="749808" cy="329184"/>
+            <a:ext cx="749808" cy="307777"/>
           </a:xfrm>
           <a:prstGeom prst="rect">
             <a:avLst/>
@@ -10187,7 +10250,7 @@
           <a:p>
             <a:pPr algn="l"/>
             <a:r>
-              <a:rPr sz="1300" b="1">
+              <a:rPr sz="1400" b="1">
                 <a:solidFill>
                   <a:srgbClr val="1A1A2E"/>
                 </a:solidFill>
@@ -10237,6 +10300,7 @@
           <a:lstStyle/>
           <a:p>
             <a:pPr algn="ctr"/>
+            <a:endParaRPr sz="2000"/>
           </a:p>
         </p:txBody>
       </p:sp>
@@ -10249,7 +10313,7 @@
         <p:spPr>
           <a:xfrm>
             <a:off x="7351775" y="3108960"/>
-            <a:ext cx="2761488" cy="329184"/>
+            <a:ext cx="2761488" cy="307777"/>
           </a:xfrm>
           <a:prstGeom prst="rect">
             <a:avLst/>
@@ -10264,7 +10328,7 @@
           <a:p>
             <a:pPr algn="l"/>
             <a:r>
-              <a:rPr sz="1300" b="0">
+              <a:rPr sz="1400" b="0">
                 <a:solidFill>
                   <a:srgbClr val="1A1A2E"/>
                 </a:solidFill>
@@ -10314,6 +10378,7 @@
           <a:lstStyle/>
           <a:p>
             <a:pPr algn="ctr"/>
+            <a:endParaRPr sz="2000"/>
           </a:p>
         </p:txBody>
       </p:sp>
@@ -10326,7 +10391,7 @@
         <p:spPr>
           <a:xfrm>
             <a:off x="10277855" y="3108960"/>
-            <a:ext cx="1298448" cy="329184"/>
+            <a:ext cx="1298448" cy="307777"/>
           </a:xfrm>
           <a:prstGeom prst="rect">
             <a:avLst/>
@@ -10341,7 +10406,7 @@
           <a:p>
             <a:pPr algn="l"/>
             <a:r>
-              <a:rPr sz="1300" b="0">
+              <a:rPr sz="1400" b="0">
                 <a:solidFill>
                   <a:srgbClr val="1A1A2E"/>
                 </a:solidFill>
@@ -10391,6 +10456,7 @@
           <a:lstStyle/>
           <a:p>
             <a:pPr algn="ctr"/>
+            <a:endParaRPr sz="2000"/>
           </a:p>
         </p:txBody>
       </p:sp>
@@ -10403,7 +10469,7 @@
         <p:spPr>
           <a:xfrm>
             <a:off x="6492240" y="3840480"/>
-            <a:ext cx="5120640" cy="2560320"/>
+            <a:ext cx="5120640" cy="1169551"/>
           </a:xfrm>
           <a:prstGeom prst="rect">
             <a:avLst/>
@@ -10418,7 +10484,7 @@
           <a:p>
             <a:pPr algn="l"/>
             <a:r>
-              <a:rPr sz="1200" b="0">
+              <a:rPr sz="1400" b="0">
                 <a:solidFill>
                   <a:srgbClr val="1A1A2E"/>
                 </a:solidFill>
@@ -10440,7 +10506,7 @@
 </file>
 
 <file path=ppt/slides/slide7.xml><?xml version="1.0" encoding="utf-8"?>
-<p:sld xmlns:a="http://schemas.openxmlformats.org/drawingml/2006/main" xmlns:p="http://schemas.openxmlformats.org/presentationml/2006/main" xmlns:r="http://schemas.openxmlformats.org/officeDocument/2006/relationships">
+<p:sld xmlns:a="http://schemas.openxmlformats.org/drawingml/2006/main" xmlns:r="http://schemas.openxmlformats.org/officeDocument/2006/relationships" xmlns:p="http://schemas.openxmlformats.org/presentationml/2006/main">
   <p:cSld>
     <p:spTree>
       <p:nvGrpSpPr>
@@ -10448,7 +10514,14 @@
         <p:cNvGrpSpPr/>
         <p:nvPr/>
       </p:nvGrpSpPr>
-      <p:grpSpPr/>
+      <p:grpSpPr>
+        <a:xfrm>
+          <a:off x="0" y="0"/>
+          <a:ext cx="0" cy="0"/>
+          <a:chOff x="0" y="0"/>
+          <a:chExt cx="0" cy="0"/>
+        </a:xfrm>
+      </p:grpSpPr>
       <p:sp>
         <p:nvSpPr>
           <p:cNvPr id="2" name="Rectangle 1"/>
@@ -10489,6 +10562,7 @@
           <a:lstStyle/>
           <a:p>
             <a:pPr algn="ctr"/>
+            <a:endParaRPr sz="2000"/>
           </a:p>
         </p:txBody>
       </p:sp>
@@ -10532,6 +10606,7 @@
           <a:lstStyle/>
           <a:p>
             <a:pPr algn="ctr"/>
+            <a:endParaRPr sz="2000"/>
           </a:p>
         </p:txBody>
       </p:sp>
@@ -10544,7 +10619,7 @@
         <p:spPr>
           <a:xfrm>
             <a:off x="274320" y="137160"/>
-            <a:ext cx="10972800" cy="731520"/>
+            <a:ext cx="10972800" cy="584775"/>
           </a:xfrm>
           <a:prstGeom prst="rect">
             <a:avLst/>
@@ -10559,7 +10634,7 @@
           <a:p>
             <a:pPr algn="l"/>
             <a:r>
-              <a:rPr sz="2800" b="1">
+              <a:rPr sz="3200" b="1">
                 <a:solidFill>
                   <a:srgbClr val="FFFFFF"/>
                 </a:solidFill>
@@ -10593,7 +10668,7 @@
           <a:p>
             <a:pPr algn="l"/>
             <a:r>
-              <a:rPr sz="1700" b="1">
+              <a:rPr b="1">
                 <a:solidFill>
                   <a:srgbClr val="2E75B6"/>
                 </a:solidFill>
@@ -10612,7 +10687,7 @@
         <p:spPr>
           <a:xfrm>
             <a:off x="365760" y="1691640"/>
-            <a:ext cx="5394960" cy="3200400"/>
+            <a:ext cx="5394960" cy="2523768"/>
           </a:xfrm>
           <a:prstGeom prst="rect">
             <a:avLst/>
@@ -10631,7 +10706,7 @@
               </a:spcAft>
             </a:pPr>
             <a:r>
-              <a:rPr sz="1400">
+              <a:rPr sz="1600">
                 <a:solidFill>
                   <a:srgbClr val="1A1A2E"/>
                 </a:solidFill>
@@ -10646,7 +10721,7 @@
               </a:spcAft>
             </a:pPr>
             <a:r>
-              <a:rPr sz="1400">
+              <a:rPr sz="1600">
                 <a:solidFill>
                   <a:srgbClr val="1A1A2E"/>
                 </a:solidFill>
@@ -10661,7 +10736,7 @@
               </a:spcAft>
             </a:pPr>
             <a:r>
-              <a:rPr sz="1400">
+              <a:rPr sz="1600">
                 <a:solidFill>
                   <a:srgbClr val="1A1A2E"/>
                 </a:solidFill>
@@ -10676,7 +10751,7 @@
               </a:spcAft>
             </a:pPr>
             <a:r>
-              <a:rPr sz="1400">
+              <a:rPr sz="1600">
                 <a:solidFill>
                   <a:srgbClr val="1A1A2E"/>
                 </a:solidFill>
@@ -10691,7 +10766,7 @@
               </a:spcAft>
             </a:pPr>
             <a:r>
-              <a:rPr sz="1400">
+              <a:rPr sz="1600">
                 <a:solidFill>
                   <a:srgbClr val="1A1A2E"/>
                 </a:solidFill>
@@ -10706,7 +10781,7 @@
               </a:spcAft>
             </a:pPr>
             <a:r>
-              <a:rPr sz="1400">
+              <a:rPr sz="1600">
                 <a:solidFill>
                   <a:srgbClr val="1A1A2E"/>
                 </a:solidFill>
@@ -10721,7 +10796,7 @@
               </a:spcAft>
             </a:pPr>
             <a:r>
-              <a:rPr sz="1400">
+              <a:rPr sz="1600">
                 <a:solidFill>
                   <a:srgbClr val="1A1A2E"/>
                 </a:solidFill>
@@ -10755,7 +10830,7 @@
           <a:p>
             <a:pPr algn="l"/>
             <a:r>
-              <a:rPr sz="1700" b="1">
+              <a:rPr b="1">
                 <a:solidFill>
                   <a:srgbClr val="2E75B6"/>
                 </a:solidFill>
@@ -10774,7 +10849,7 @@
         <p:spPr>
           <a:xfrm>
             <a:off x="6492240" y="1691640"/>
-            <a:ext cx="5394960" cy="3200400"/>
+            <a:ext cx="5394960" cy="2200602"/>
           </a:xfrm>
           <a:prstGeom prst="rect">
             <a:avLst/>
@@ -10793,7 +10868,7 @@
               </a:spcAft>
             </a:pPr>
             <a:r>
-              <a:rPr sz="1400">
+              <a:rPr sz="1600">
                 <a:solidFill>
                   <a:srgbClr val="1A1A2E"/>
                 </a:solidFill>
@@ -10808,7 +10883,7 @@
               </a:spcAft>
             </a:pPr>
             <a:r>
-              <a:rPr sz="1400">
+              <a:rPr sz="1600">
                 <a:solidFill>
                   <a:srgbClr val="1A1A2E"/>
                 </a:solidFill>
@@ -10823,7 +10898,7 @@
               </a:spcAft>
             </a:pPr>
             <a:r>
-              <a:rPr sz="1400">
+              <a:rPr sz="1600">
                 <a:solidFill>
                   <a:srgbClr val="1A1A2E"/>
                 </a:solidFill>
@@ -10838,7 +10913,7 @@
               </a:spcAft>
             </a:pPr>
             <a:r>
-              <a:rPr sz="1400">
+              <a:rPr sz="1600">
                 <a:solidFill>
                   <a:srgbClr val="1A1A2E"/>
                 </a:solidFill>
@@ -10853,7 +10928,7 @@
               </a:spcAft>
             </a:pPr>
             <a:r>
-              <a:rPr sz="1400">
+              <a:rPr sz="1600">
                 <a:solidFill>
                   <a:srgbClr val="1A1A2E"/>
                 </a:solidFill>
@@ -10868,7 +10943,7 @@
               </a:spcAft>
             </a:pPr>
             <a:r>
-              <a:rPr sz="1400">
+              <a:rPr sz="1600">
                 <a:solidFill>
                   <a:srgbClr val="1A1A2E"/>
                 </a:solidFill>
@@ -10918,6 +10993,7 @@
           <a:lstStyle/>
           <a:p>
             <a:pPr algn="ctr"/>
+            <a:endParaRPr sz="2000"/>
           </a:p>
         </p:txBody>
       </p:sp>
@@ -10929,8 +11005,8 @@
         </p:nvSpPr>
         <p:spPr>
           <a:xfrm>
-            <a:off x="548640" y="5120640"/>
-            <a:ext cx="11064240" cy="1371600"/>
+            <a:off x="444312" y="5529103"/>
+            <a:ext cx="11064240" cy="1200329"/>
           </a:xfrm>
           <a:prstGeom prst="rect">
             <a:avLst/>
@@ -10945,14 +11021,14 @@
           <a:p>
             <a:pPr algn="ctr"/>
             <a:r>
-              <a:rPr sz="1600" b="0">
+              <a:rPr b="0" dirty="0">
                 <a:solidFill>
                   <a:srgbClr val="FFFFFF"/>
                 </a:solidFill>
               </a:rPr>
               <a:t>"This project demonstrated that a fully functional IoT system can be built and validated
 entirely through software simulation — without any physical hardware."
-Thank you  |  Questions?</a:t>
+</a:t>
             </a:r>
           </a:p>
         </p:txBody>

</xml_diff>